<commit_message>
presentation: split slide 6 into 2 (1×2 big screenshots per slide instead of 2×2 small)
</commit_message>
<xml_diff>
--- a/presentation/Planwise-Klassniy-Chas.pptx
+++ b/presentation/Planwise-Klassniy-Chas.pptx
@@ -18,9 +18,10 @@
     <p:sldId id="266" r:id="rId12"/>
     <p:sldId id="267" r:id="rId13"/>
     <p:sldId id="268" r:id="rId14"/>
+    <p:sldId id="269" r:id="rId15"/>
   </p:sldIdLst>
   <p:notesMasterIdLst>
-    <p:notesMasterId r:id="rId15"/>
+    <p:notesMasterId r:id="rId16"/>
   </p:notesMasterIdLst>
   <p:sldSz cx="12192000" cy="6858000"/>
   <p:notesSz cx="6858000" cy="12192000"/>
@@ -890,6 +891,94 @@
             <a:fld id="{F7021451-1387-4CA6-816F-3879F97B5CBC}" type="slidenum">
               <a:rPr lang="en-US"/>
               <a:t>13</a:t>
+            </a:fld>
+            <a:endParaRPr lang="en-US"/>
+          </a:p>
+        </p:txBody>
+      </p:sp>
+    </p:spTree>
+    <p:extLst>
+      <p:ext uri="{BB962C8B-B14F-4D97-AF65-F5344CB8AC3E}">
+        <p14:creationId xmlns:p14="http://schemas.microsoft.com/office/powerpoint/2010/main" val="1024086991"/>
+      </p:ext>
+    </p:extLst>
+  </p:cSld>
+  <p:clrMapOvr>
+    <a:masterClrMapping/>
+  </p:clrMapOvr>
+</p:notes>
+</file>
+
+<file path=ppt/notesSlides/notesSlide14.xml><?xml version="1.0" encoding="utf-8"?>
+<p:notes xmlns:a="http://schemas.openxmlformats.org/drawingml/2006/main" xmlns:r="http://schemas.openxmlformats.org/officeDocument/2006/relationships" xmlns:p="http://schemas.openxmlformats.org/presentationml/2006/main">
+  <p:cSld>
+    <p:spTree>
+      <p:nvGrpSpPr>
+        <p:cNvPr id="1" name=""/>
+        <p:cNvGrpSpPr/>
+        <p:nvPr/>
+      </p:nvGrpSpPr>
+      <p:grpSpPr>
+        <a:xfrm>
+          <a:off x="0" y="0"/>
+          <a:ext cx="0" cy="0"/>
+          <a:chOff x="0" y="0"/>
+          <a:chExt cx="0" cy="0"/>
+        </a:xfrm>
+      </p:grpSpPr>
+      <p:sp>
+        <p:nvSpPr>
+          <p:cNvPr id="2" name="Slide Image Placeholder 1"/>
+          <p:cNvSpPr>
+            <a:spLocks noGrp="1" noRot="1" noChangeAspect="1"/>
+          </p:cNvSpPr>
+          <p:nvPr>
+            <p:ph type="sldImg"/>
+          </p:nvPr>
+        </p:nvSpPr>
+        <p:spPr/>
+      </p:sp>
+      <p:sp>
+        <p:nvSpPr>
+          <p:cNvPr id="3" name="Notes Placeholder 2"/>
+          <p:cNvSpPr>
+            <a:spLocks noGrp="1"/>
+          </p:cNvSpPr>
+          <p:nvPr>
+            <p:ph type="body" idx="1"/>
+          </p:nvPr>
+        </p:nvSpPr>
+        <p:spPr/>
+        <p:txBody>
+          <a:bodyPr/>
+          <a:lstStyle/>
+          <a:p>
+            <a:r>
+              <a:rPr lang="en-US" dirty="0"/>
+              <a:t/>
+            </a:r>
+            <a:endParaRPr lang="en-US" dirty="0"/>
+          </a:p>
+        </p:txBody>
+      </p:sp>
+      <p:sp>
+        <p:nvSpPr>
+          <p:cNvPr id="4" name="Slide Number Placeholder 3"/>
+          <p:cNvSpPr>
+            <a:spLocks noGrp="1"/>
+          </p:cNvSpPr>
+          <p:nvPr>
+            <p:ph type="sldNum" sz="quarter" idx="10"/>
+          </p:nvPr>
+        </p:nvSpPr>
+        <p:spPr/>
+        <p:txBody>
+          <a:bodyPr/>
+          <a:lstStyle/>
+          <a:p>
+            <a:fld id="{F7021451-1387-4CA6-816F-3879F97B5CBC}" type="slidenum">
+              <a:rPr lang="en-US"/>
+              <a:t>14</a:t>
             </a:fld>
             <a:endParaRPr lang="en-US"/>
           </a:p>
@@ -2434,7 +2523,7 @@
                 <a:ea typeface="Calibri" pitchFamily="34" charset="-122"/>
                 <a:cs typeface="Calibri" pitchFamily="34" charset="-120"/>
               </a:rPr>
-              <a:t>08 — РИСКИ</a:t>
+              <a:t>07 — ДОРОЖНАЯ КАРТА</a:t>
             </a:r>
             <a:endParaRPr lang="en-US" sz="1300" dirty="0"/>
           </a:p>
@@ -2473,6 +2562,1162 @@
                 <a:ea typeface="Georgia" pitchFamily="34" charset="-122"/>
                 <a:cs typeface="Georgia" pitchFamily="34" charset="-120"/>
               </a:rPr>
+              <a:t>От MVP к масштабу</a:t>
+            </a:r>
+            <a:endParaRPr lang="en-US" sz="3200" dirty="0"/>
+          </a:p>
+        </p:txBody>
+      </p:sp>
+      <p:sp>
+        <p:nvSpPr>
+          <p:cNvPr id="5" name="Shape 3"/>
+          <p:cNvSpPr/>
+          <p:nvPr/>
+        </p:nvSpPr>
+        <p:spPr>
+          <a:xfrm>
+            <a:off x="914400" y="2468880"/>
+            <a:ext cx="10332720" cy="0"/>
+          </a:xfrm>
+          <a:prstGeom prst="line">
+            <a:avLst/>
+          </a:prstGeom>
+          <a:noFill/>
+          <a:ln w="25400">
+            <a:solidFill>
+              <a:srgbClr val="E4E6E1"/>
+            </a:solidFill>
+            <a:prstDash val="solid"/>
+          </a:ln>
+        </p:spPr>
+      </p:sp>
+      <p:sp>
+        <p:nvSpPr>
+          <p:cNvPr id="6" name="Shape 4"/>
+          <p:cNvSpPr/>
+          <p:nvPr/>
+        </p:nvSpPr>
+        <p:spPr>
+          <a:xfrm>
+            <a:off x="960120" y="2286000"/>
+            <a:ext cx="365760" cy="365760"/>
+          </a:xfrm>
+          <a:prstGeom prst="ellipse">
+            <a:avLst/>
+          </a:prstGeom>
+          <a:solidFill>
+            <a:srgbClr val="21A663"/>
+          </a:solidFill>
+          <a:ln/>
+        </p:spPr>
+      </p:sp>
+      <p:sp>
+        <p:nvSpPr>
+          <p:cNvPr id="7" name="Text 5"/>
+          <p:cNvSpPr/>
+          <p:nvPr/>
+        </p:nvSpPr>
+        <p:spPr>
+          <a:xfrm>
+            <a:off x="960120" y="2286000"/>
+            <a:ext cx="365760" cy="365760"/>
+          </a:xfrm>
+          <a:prstGeom prst="rect">
+            <a:avLst/>
+          </a:prstGeom>
+          <a:noFill/>
+          <a:ln/>
+        </p:spPr>
+        <p:txBody>
+          <a:bodyPr wrap="square" rtlCol="0" anchor="ctr"/>
+          <a:lstStyle/>
+          <a:p>
+            <a:pPr algn="ctr" indent="0" marL="0">
+              <a:buNone/>
+            </a:pPr>
+            <a:r>
+              <a:rPr lang="en-US" sz="1300" b="1" dirty="0">
+                <a:solidFill>
+                  <a:srgbClr val="FFFFFF"/>
+                </a:solidFill>
+                <a:latin typeface="Georgia" pitchFamily="34" charset="0"/>
+                <a:ea typeface="Georgia" pitchFamily="34" charset="-122"/>
+                <a:cs typeface="Georgia" pitchFamily="34" charset="-120"/>
+              </a:rPr>
+              <a:t>1</a:t>
+            </a:r>
+            <a:endParaRPr lang="en-US" sz="1300" dirty="0"/>
+          </a:p>
+        </p:txBody>
+      </p:sp>
+      <p:sp>
+        <p:nvSpPr>
+          <p:cNvPr id="8" name="Shape 6"/>
+          <p:cNvSpPr/>
+          <p:nvPr/>
+        </p:nvSpPr>
+        <p:spPr>
+          <a:xfrm>
+            <a:off x="640080" y="2926080"/>
+            <a:ext cx="2606040" cy="2651760"/>
+          </a:xfrm>
+          <a:prstGeom prst="rect">
+            <a:avLst/>
+          </a:prstGeom>
+          <a:solidFill>
+            <a:srgbClr val="FFFFFF"/>
+          </a:solidFill>
+          <a:ln w="12700">
+            <a:solidFill>
+              <a:srgbClr val="E4E6E1"/>
+            </a:solidFill>
+            <a:prstDash val="solid"/>
+          </a:ln>
+          <a:effectLst>
+            <a:outerShdw sx="100000" sy="100000" kx="0" ky="0" algn="bl" rotWithShape="0" blurRad="101600" dist="38100" dir="8100000">
+              <a:srgbClr val="000000">
+                <a:alpha val="12000"/>
+              </a:srgbClr>
+            </a:outerShdw>
+          </a:effectLst>
+        </p:spPr>
+      </p:sp>
+      <p:sp>
+        <p:nvSpPr>
+          <p:cNvPr id="9" name="Shape 7"/>
+          <p:cNvSpPr/>
+          <p:nvPr/>
+        </p:nvSpPr>
+        <p:spPr>
+          <a:xfrm>
+            <a:off x="640080" y="2926080"/>
+            <a:ext cx="2606040" cy="109728"/>
+          </a:xfrm>
+          <a:prstGeom prst="rect">
+            <a:avLst/>
+          </a:prstGeom>
+          <a:solidFill>
+            <a:srgbClr val="21A663"/>
+          </a:solidFill>
+          <a:ln/>
+        </p:spPr>
+      </p:sp>
+      <p:sp>
+        <p:nvSpPr>
+          <p:cNvPr id="10" name="Text 8"/>
+          <p:cNvSpPr/>
+          <p:nvPr/>
+        </p:nvSpPr>
+        <p:spPr>
+          <a:xfrm>
+            <a:off x="841248" y="3127248"/>
+            <a:ext cx="2240280" cy="457200"/>
+          </a:xfrm>
+          <a:prstGeom prst="rect">
+            <a:avLst/>
+          </a:prstGeom>
+          <a:noFill/>
+          <a:ln/>
+        </p:spPr>
+        <p:txBody>
+          <a:bodyPr wrap="square" rtlCol="0" anchor="ctr"/>
+          <a:lstStyle/>
+          <a:p>
+            <a:pPr indent="0" marL="0">
+              <a:buNone/>
+            </a:pPr>
+            <a:r>
+              <a:rPr lang="en-US" sz="1600" b="1" dirty="0">
+                <a:solidFill>
+                  <a:srgbClr val="14160F"/>
+                </a:solidFill>
+                <a:latin typeface="Georgia" pitchFamily="34" charset="0"/>
+                <a:ea typeface="Georgia" pitchFamily="34" charset="-122"/>
+                <a:cs typeface="Georgia" pitchFamily="34" charset="-120"/>
+              </a:rPr>
+              <a:t>Развёрнуто на проде</a:t>
+            </a:r>
+            <a:endParaRPr lang="en-US" sz="1600" dirty="0"/>
+          </a:p>
+        </p:txBody>
+      </p:sp>
+      <p:sp>
+        <p:nvSpPr>
+          <p:cNvPr id="11" name="Text 9"/>
+          <p:cNvSpPr/>
+          <p:nvPr/>
+        </p:nvSpPr>
+        <p:spPr>
+          <a:xfrm>
+            <a:off x="868680" y="3657600"/>
+            <a:ext cx="2194560" cy="1828800"/>
+          </a:xfrm>
+          <a:prstGeom prst="rect">
+            <a:avLst/>
+          </a:prstGeom>
+          <a:noFill/>
+          <a:ln/>
+        </p:spPr>
+        <p:txBody>
+          <a:bodyPr wrap="square" rtlCol="0" anchor="t"/>
+          <a:lstStyle/>
+          <a:p>
+            <a:pPr marL="342900" indent="-342900">
+              <a:spcAft>
+                <a:spcPts val="800"/>
+              </a:spcAft>
+              <a:buSzPct val="100000"/>
+              <a:buChar char="•"/>
+            </a:pPr>
+            <a:r>
+              <a:rPr lang="en-US" sz="1200" dirty="0">
+                <a:solidFill>
+                  <a:srgbClr val="717670"/>
+                </a:solidFill>
+                <a:latin typeface="Calibri" pitchFamily="34" charset="0"/>
+                <a:ea typeface="Calibri" pitchFamily="34" charset="-122"/>
+                <a:cs typeface="Calibri" pitchFamily="34" charset="-120"/>
+              </a:rPr>
+              <a:t>MVP + RAG-корпус методичек РоВ · домен plan-wise.ru + HTTPS</a:t>
+            </a:r>
+            <a:endParaRPr lang="en-US" sz="1200" dirty="0"/>
+          </a:p>
+          <a:p>
+            <a:pPr marL="342900" indent="-342900">
+              <a:spcAft>
+                <a:spcPts val="800"/>
+              </a:spcAft>
+              <a:buSzPct val="100000"/>
+              <a:buChar char="•"/>
+            </a:pPr>
+            <a:r>
+              <a:rPr lang="en-US" sz="1200" dirty="0">
+                <a:solidFill>
+                  <a:srgbClr val="717670"/>
+                </a:solidFill>
+                <a:latin typeface="Calibri" pitchFamily="34" charset="0"/>
+                <a:ea typeface="Calibri" pitchFamily="34" charset="-122"/>
+                <a:cs typeface="Calibri" pitchFamily="34" charset="-120"/>
+              </a:rPr>
+              <a:t>Docker Compose · библиотека наполнена · порог откалиброван</a:t>
+            </a:r>
+            <a:endParaRPr lang="en-US" sz="1200" dirty="0"/>
+          </a:p>
+        </p:txBody>
+      </p:sp>
+      <p:sp>
+        <p:nvSpPr>
+          <p:cNvPr id="12" name="Text 10"/>
+          <p:cNvSpPr/>
+          <p:nvPr/>
+        </p:nvSpPr>
+        <p:spPr>
+          <a:xfrm>
+            <a:off x="3246120" y="3931920"/>
+            <a:ext cx="182880" cy="365760"/>
+          </a:xfrm>
+          <a:prstGeom prst="rect">
+            <a:avLst/>
+          </a:prstGeom>
+          <a:noFill/>
+          <a:ln/>
+        </p:spPr>
+        <p:txBody>
+          <a:bodyPr wrap="square" rtlCol="0" anchor="ctr"/>
+          <a:lstStyle/>
+          <a:p>
+            <a:pPr algn="ctr" indent="0" marL="0">
+              <a:buNone/>
+            </a:pPr>
+            <a:r>
+              <a:rPr lang="en-US" sz="1800" b="1" dirty="0">
+                <a:solidFill>
+                  <a:srgbClr val="21A663"/>
+                </a:solidFill>
+              </a:rPr>
+              <a:t>→</a:t>
+            </a:r>
+            <a:endParaRPr lang="en-US" sz="1800" dirty="0"/>
+          </a:p>
+        </p:txBody>
+      </p:sp>
+      <p:sp>
+        <p:nvSpPr>
+          <p:cNvPr id="13" name="Shape 11"/>
+          <p:cNvSpPr/>
+          <p:nvPr/>
+        </p:nvSpPr>
+        <p:spPr>
+          <a:xfrm>
+            <a:off x="3749040" y="2286000"/>
+            <a:ext cx="365760" cy="365760"/>
+          </a:xfrm>
+          <a:prstGeom prst="ellipse">
+            <a:avLst/>
+          </a:prstGeom>
+          <a:solidFill>
+            <a:srgbClr val="F5B800"/>
+          </a:solidFill>
+          <a:ln/>
+        </p:spPr>
+      </p:sp>
+      <p:sp>
+        <p:nvSpPr>
+          <p:cNvPr id="14" name="Text 12"/>
+          <p:cNvSpPr/>
+          <p:nvPr/>
+        </p:nvSpPr>
+        <p:spPr>
+          <a:xfrm>
+            <a:off x="3749040" y="2286000"/>
+            <a:ext cx="365760" cy="365760"/>
+          </a:xfrm>
+          <a:prstGeom prst="rect">
+            <a:avLst/>
+          </a:prstGeom>
+          <a:noFill/>
+          <a:ln/>
+        </p:spPr>
+        <p:txBody>
+          <a:bodyPr wrap="square" rtlCol="0" anchor="ctr"/>
+          <a:lstStyle/>
+          <a:p>
+            <a:pPr algn="ctr" indent="0" marL="0">
+              <a:buNone/>
+            </a:pPr>
+            <a:r>
+              <a:rPr lang="en-US" sz="1300" b="1" dirty="0">
+                <a:solidFill>
+                  <a:srgbClr val="FFFFFF"/>
+                </a:solidFill>
+                <a:latin typeface="Georgia" pitchFamily="34" charset="0"/>
+                <a:ea typeface="Georgia" pitchFamily="34" charset="-122"/>
+                <a:cs typeface="Georgia" pitchFamily="34" charset="-120"/>
+              </a:rPr>
+              <a:t>2</a:t>
+            </a:r>
+            <a:endParaRPr lang="en-US" sz="1300" dirty="0"/>
+          </a:p>
+        </p:txBody>
+      </p:sp>
+      <p:sp>
+        <p:nvSpPr>
+          <p:cNvPr id="15" name="Shape 13"/>
+          <p:cNvSpPr/>
+          <p:nvPr/>
+        </p:nvSpPr>
+        <p:spPr>
+          <a:xfrm>
+            <a:off x="3429000" y="2926080"/>
+            <a:ext cx="2606040" cy="2651760"/>
+          </a:xfrm>
+          <a:prstGeom prst="rect">
+            <a:avLst/>
+          </a:prstGeom>
+          <a:solidFill>
+            <a:srgbClr val="FFFFFF"/>
+          </a:solidFill>
+          <a:ln w="12700">
+            <a:solidFill>
+              <a:srgbClr val="E4E6E1"/>
+            </a:solidFill>
+            <a:prstDash val="solid"/>
+          </a:ln>
+          <a:effectLst>
+            <a:outerShdw sx="100000" sy="100000" kx="0" ky="0" algn="bl" rotWithShape="0" blurRad="101600" dist="38100" dir="8100000">
+              <a:srgbClr val="000000">
+                <a:alpha val="12000"/>
+              </a:srgbClr>
+            </a:outerShdw>
+          </a:effectLst>
+        </p:spPr>
+      </p:sp>
+      <p:sp>
+        <p:nvSpPr>
+          <p:cNvPr id="16" name="Shape 14"/>
+          <p:cNvSpPr/>
+          <p:nvPr/>
+        </p:nvSpPr>
+        <p:spPr>
+          <a:xfrm>
+            <a:off x="3429000" y="2926080"/>
+            <a:ext cx="2606040" cy="109728"/>
+          </a:xfrm>
+          <a:prstGeom prst="rect">
+            <a:avLst/>
+          </a:prstGeom>
+          <a:solidFill>
+            <a:srgbClr val="F5B800"/>
+          </a:solidFill>
+          <a:ln/>
+        </p:spPr>
+      </p:sp>
+      <p:sp>
+        <p:nvSpPr>
+          <p:cNvPr id="17" name="Text 15"/>
+          <p:cNvSpPr/>
+          <p:nvPr/>
+        </p:nvSpPr>
+        <p:spPr>
+          <a:xfrm>
+            <a:off x="3630168" y="3127248"/>
+            <a:ext cx="2240280" cy="457200"/>
+          </a:xfrm>
+          <a:prstGeom prst="rect">
+            <a:avLst/>
+          </a:prstGeom>
+          <a:noFill/>
+          <a:ln/>
+        </p:spPr>
+        <p:txBody>
+          <a:bodyPr wrap="square" rtlCol="0" anchor="ctr"/>
+          <a:lstStyle/>
+          <a:p>
+            <a:pPr indent="0" marL="0">
+              <a:buNone/>
+            </a:pPr>
+            <a:r>
+              <a:rPr lang="en-US" sz="1600" b="1" dirty="0">
+                <a:solidFill>
+                  <a:srgbClr val="14160F"/>
+                </a:solidFill>
+                <a:latin typeface="Georgia" pitchFamily="34" charset="0"/>
+                <a:ea typeface="Georgia" pitchFamily="34" charset="-122"/>
+                <a:cs typeface="Georgia" pitchFamily="34" charset="-120"/>
+              </a:rPr>
+              <a:t>Перед демо</a:t>
+            </a:r>
+            <a:endParaRPr lang="en-US" sz="1600" dirty="0"/>
+          </a:p>
+        </p:txBody>
+      </p:sp>
+      <p:sp>
+        <p:nvSpPr>
+          <p:cNvPr id="18" name="Text 16"/>
+          <p:cNvSpPr/>
+          <p:nvPr/>
+        </p:nvSpPr>
+        <p:spPr>
+          <a:xfrm>
+            <a:off x="3657600" y="3657600"/>
+            <a:ext cx="2194560" cy="1828800"/>
+          </a:xfrm>
+          <a:prstGeom prst="rect">
+            <a:avLst/>
+          </a:prstGeom>
+          <a:noFill/>
+          <a:ln/>
+        </p:spPr>
+        <p:txBody>
+          <a:bodyPr wrap="square" rtlCol="0" anchor="t"/>
+          <a:lstStyle/>
+          <a:p>
+            <a:pPr marL="342900" indent="-342900">
+              <a:spcAft>
+                <a:spcPts val="800"/>
+              </a:spcAft>
+              <a:buSzPct val="100000"/>
+              <a:buChar char="•"/>
+            </a:pPr>
+            <a:r>
+              <a:rPr lang="en-US" sz="1200" dirty="0">
+                <a:solidFill>
+                  <a:srgbClr val="717670"/>
+                </a:solidFill>
+                <a:latin typeface="Calibri" pitchFamily="34" charset="0"/>
+                <a:ea typeface="Calibri" pitchFamily="34" charset="-122"/>
+                <a:cs typeface="Calibri" pitchFamily="34" charset="-120"/>
+              </a:rPr>
+              <a:t>Живой UAT golden-path</a:t>
+            </a:r>
+            <a:endParaRPr lang="en-US" sz="1200" dirty="0"/>
+          </a:p>
+          <a:p>
+            <a:pPr marL="342900" indent="-342900">
+              <a:spcAft>
+                <a:spcPts val="800"/>
+              </a:spcAft>
+              <a:buSzPct val="100000"/>
+              <a:buChar char="•"/>
+            </a:pPr>
+            <a:r>
+              <a:rPr lang="en-US" sz="1200" dirty="0">
+                <a:solidFill>
+                  <a:srgbClr val="717670"/>
+                </a:solidFill>
+                <a:latin typeface="Calibri" pitchFamily="34" charset="0"/>
+                <a:ea typeface="Calibri" pitchFamily="34" charset="-122"/>
+                <a:cs typeface="Calibri" pitchFamily="34" charset="-120"/>
+              </a:rPr>
+              <a:t>Скринкаст 5–7 мин + презентация</a:t>
+            </a:r>
+            <a:endParaRPr lang="en-US" sz="1200" dirty="0"/>
+          </a:p>
+        </p:txBody>
+      </p:sp>
+      <p:sp>
+        <p:nvSpPr>
+          <p:cNvPr id="19" name="Text 17"/>
+          <p:cNvSpPr/>
+          <p:nvPr/>
+        </p:nvSpPr>
+        <p:spPr>
+          <a:xfrm>
+            <a:off x="6035040" y="3931920"/>
+            <a:ext cx="182880" cy="365760"/>
+          </a:xfrm>
+          <a:prstGeom prst="rect">
+            <a:avLst/>
+          </a:prstGeom>
+          <a:noFill/>
+          <a:ln/>
+        </p:spPr>
+        <p:txBody>
+          <a:bodyPr wrap="square" rtlCol="0" anchor="ctr"/>
+          <a:lstStyle/>
+          <a:p>
+            <a:pPr algn="ctr" indent="0" marL="0">
+              <a:buNone/>
+            </a:pPr>
+            <a:r>
+              <a:rPr lang="en-US" sz="1800" b="1" dirty="0">
+                <a:solidFill>
+                  <a:srgbClr val="21A663"/>
+                </a:solidFill>
+              </a:rPr>
+              <a:t>→</a:t>
+            </a:r>
+            <a:endParaRPr lang="en-US" sz="1800" dirty="0"/>
+          </a:p>
+        </p:txBody>
+      </p:sp>
+      <p:sp>
+        <p:nvSpPr>
+          <p:cNvPr id="20" name="Shape 18"/>
+          <p:cNvSpPr/>
+          <p:nvPr/>
+        </p:nvSpPr>
+        <p:spPr>
+          <a:xfrm>
+            <a:off x="6537960" y="2286000"/>
+            <a:ext cx="365760" cy="365760"/>
+          </a:xfrm>
+          <a:prstGeom prst="ellipse">
+            <a:avLst/>
+          </a:prstGeom>
+          <a:solidFill>
+            <a:srgbClr val="2741E0"/>
+          </a:solidFill>
+          <a:ln/>
+        </p:spPr>
+      </p:sp>
+      <p:sp>
+        <p:nvSpPr>
+          <p:cNvPr id="21" name="Text 19"/>
+          <p:cNvSpPr/>
+          <p:nvPr/>
+        </p:nvSpPr>
+        <p:spPr>
+          <a:xfrm>
+            <a:off x="6537960" y="2286000"/>
+            <a:ext cx="365760" cy="365760"/>
+          </a:xfrm>
+          <a:prstGeom prst="rect">
+            <a:avLst/>
+          </a:prstGeom>
+          <a:noFill/>
+          <a:ln/>
+        </p:spPr>
+        <p:txBody>
+          <a:bodyPr wrap="square" rtlCol="0" anchor="ctr"/>
+          <a:lstStyle/>
+          <a:p>
+            <a:pPr algn="ctr" indent="0" marL="0">
+              <a:buNone/>
+            </a:pPr>
+            <a:r>
+              <a:rPr lang="en-US" sz="1300" b="1" dirty="0">
+                <a:solidFill>
+                  <a:srgbClr val="FFFFFF"/>
+                </a:solidFill>
+                <a:latin typeface="Georgia" pitchFamily="34" charset="0"/>
+                <a:ea typeface="Georgia" pitchFamily="34" charset="-122"/>
+                <a:cs typeface="Georgia" pitchFamily="34" charset="-120"/>
+              </a:rPr>
+              <a:t>3</a:t>
+            </a:r>
+            <a:endParaRPr lang="en-US" sz="1300" dirty="0"/>
+          </a:p>
+        </p:txBody>
+      </p:sp>
+      <p:sp>
+        <p:nvSpPr>
+          <p:cNvPr id="22" name="Shape 20"/>
+          <p:cNvSpPr/>
+          <p:nvPr/>
+        </p:nvSpPr>
+        <p:spPr>
+          <a:xfrm>
+            <a:off x="6217920" y="2926080"/>
+            <a:ext cx="2606040" cy="2651760"/>
+          </a:xfrm>
+          <a:prstGeom prst="rect">
+            <a:avLst/>
+          </a:prstGeom>
+          <a:solidFill>
+            <a:srgbClr val="FFFFFF"/>
+          </a:solidFill>
+          <a:ln w="12700">
+            <a:solidFill>
+              <a:srgbClr val="E4E6E1"/>
+            </a:solidFill>
+            <a:prstDash val="solid"/>
+          </a:ln>
+          <a:effectLst>
+            <a:outerShdw sx="100000" sy="100000" kx="0" ky="0" algn="bl" rotWithShape="0" blurRad="101600" dist="38100" dir="8100000">
+              <a:srgbClr val="000000">
+                <a:alpha val="12000"/>
+              </a:srgbClr>
+            </a:outerShdw>
+          </a:effectLst>
+        </p:spPr>
+      </p:sp>
+      <p:sp>
+        <p:nvSpPr>
+          <p:cNvPr id="23" name="Shape 21"/>
+          <p:cNvSpPr/>
+          <p:nvPr/>
+        </p:nvSpPr>
+        <p:spPr>
+          <a:xfrm>
+            <a:off x="6217920" y="2926080"/>
+            <a:ext cx="2606040" cy="109728"/>
+          </a:xfrm>
+          <a:prstGeom prst="rect">
+            <a:avLst/>
+          </a:prstGeom>
+          <a:solidFill>
+            <a:srgbClr val="2741E0"/>
+          </a:solidFill>
+          <a:ln/>
+        </p:spPr>
+      </p:sp>
+      <p:sp>
+        <p:nvSpPr>
+          <p:cNvPr id="24" name="Text 22"/>
+          <p:cNvSpPr/>
+          <p:nvPr/>
+        </p:nvSpPr>
+        <p:spPr>
+          <a:xfrm>
+            <a:off x="6419088" y="3127248"/>
+            <a:ext cx="2240280" cy="457200"/>
+          </a:xfrm>
+          <a:prstGeom prst="rect">
+            <a:avLst/>
+          </a:prstGeom>
+          <a:noFill/>
+          <a:ln/>
+        </p:spPr>
+        <p:txBody>
+          <a:bodyPr wrap="square" rtlCol="0" anchor="ctr"/>
+          <a:lstStyle/>
+          <a:p>
+            <a:pPr indent="0" marL="0">
+              <a:buNone/>
+            </a:pPr>
+            <a:r>
+              <a:rPr lang="en-US" sz="1600" b="1" dirty="0">
+                <a:solidFill>
+                  <a:srgbClr val="14160F"/>
+                </a:solidFill>
+                <a:latin typeface="Georgia" pitchFamily="34" charset="0"/>
+                <a:ea typeface="Georgia" pitchFamily="34" charset="-122"/>
+                <a:cs typeface="Georgia" pitchFamily="34" charset="-120"/>
+              </a:rPr>
+              <a:t>Пилот в школе</a:t>
+            </a:r>
+            <a:endParaRPr lang="en-US" sz="1600" dirty="0"/>
+          </a:p>
+        </p:txBody>
+      </p:sp>
+      <p:sp>
+        <p:nvSpPr>
+          <p:cNvPr id="25" name="Text 23"/>
+          <p:cNvSpPr/>
+          <p:nvPr/>
+        </p:nvSpPr>
+        <p:spPr>
+          <a:xfrm>
+            <a:off x="6446520" y="3657600"/>
+            <a:ext cx="2194560" cy="1828800"/>
+          </a:xfrm>
+          <a:prstGeom prst="rect">
+            <a:avLst/>
+          </a:prstGeom>
+          <a:noFill/>
+          <a:ln/>
+        </p:spPr>
+        <p:txBody>
+          <a:bodyPr wrap="square" rtlCol="0" anchor="t"/>
+          <a:lstStyle/>
+          <a:p>
+            <a:pPr marL="342900" indent="-342900">
+              <a:spcAft>
+                <a:spcPts val="800"/>
+              </a:spcAft>
+              <a:buSzPct val="100000"/>
+              <a:buChar char="•"/>
+            </a:pPr>
+            <a:r>
+              <a:rPr lang="en-US" sz="1200" dirty="0">
+                <a:solidFill>
+                  <a:srgbClr val="717670"/>
+                </a:solidFill>
+                <a:latin typeface="Calibri" pitchFamily="34" charset="0"/>
+                <a:ea typeface="Calibri" pitchFamily="34" charset="-122"/>
+                <a:cs typeface="Calibri" pitchFamily="34" charset="-120"/>
+              </a:rPr>
+              <a:t>Обкатка с реальными классными руководителями</a:t>
+            </a:r>
+            <a:endParaRPr lang="en-US" sz="1200" dirty="0"/>
+          </a:p>
+          <a:p>
+            <a:pPr marL="342900" indent="-342900">
+              <a:spcAft>
+                <a:spcPts val="800"/>
+              </a:spcAft>
+              <a:buSzPct val="100000"/>
+              <a:buChar char="•"/>
+            </a:pPr>
+            <a:r>
+              <a:rPr lang="en-US" sz="1200" dirty="0">
+                <a:solidFill>
+                  <a:srgbClr val="717670"/>
+                </a:solidFill>
+                <a:latin typeface="Calibri" pitchFamily="34" charset="0"/>
+                <a:ea typeface="Calibri" pitchFamily="34" charset="-122"/>
+                <a:cs typeface="Calibri" pitchFamily="34" charset="-120"/>
+              </a:rPr>
+              <a:t>Модерация контента методистами</a:t>
+            </a:r>
+            <a:endParaRPr lang="en-US" sz="1200" dirty="0"/>
+          </a:p>
+        </p:txBody>
+      </p:sp>
+      <p:sp>
+        <p:nvSpPr>
+          <p:cNvPr id="26" name="Text 24"/>
+          <p:cNvSpPr/>
+          <p:nvPr/>
+        </p:nvSpPr>
+        <p:spPr>
+          <a:xfrm>
+            <a:off x="8823960" y="3931920"/>
+            <a:ext cx="182880" cy="365760"/>
+          </a:xfrm>
+          <a:prstGeom prst="rect">
+            <a:avLst/>
+          </a:prstGeom>
+          <a:noFill/>
+          <a:ln/>
+        </p:spPr>
+        <p:txBody>
+          <a:bodyPr wrap="square" rtlCol="0" anchor="ctr"/>
+          <a:lstStyle/>
+          <a:p>
+            <a:pPr algn="ctr" indent="0" marL="0">
+              <a:buNone/>
+            </a:pPr>
+            <a:r>
+              <a:rPr lang="en-US" sz="1800" b="1" dirty="0">
+                <a:solidFill>
+                  <a:srgbClr val="21A663"/>
+                </a:solidFill>
+              </a:rPr>
+              <a:t>→</a:t>
+            </a:r>
+            <a:endParaRPr lang="en-US" sz="1800" dirty="0"/>
+          </a:p>
+        </p:txBody>
+      </p:sp>
+      <p:sp>
+        <p:nvSpPr>
+          <p:cNvPr id="27" name="Shape 25"/>
+          <p:cNvSpPr/>
+          <p:nvPr/>
+        </p:nvSpPr>
+        <p:spPr>
+          <a:xfrm>
+            <a:off x="9326880" y="2286000"/>
+            <a:ext cx="365760" cy="365760"/>
+          </a:xfrm>
+          <a:prstGeom prst="ellipse">
+            <a:avLst/>
+          </a:prstGeom>
+          <a:solidFill>
+            <a:srgbClr val="093520"/>
+          </a:solidFill>
+          <a:ln/>
+        </p:spPr>
+      </p:sp>
+      <p:sp>
+        <p:nvSpPr>
+          <p:cNvPr id="28" name="Text 26"/>
+          <p:cNvSpPr/>
+          <p:nvPr/>
+        </p:nvSpPr>
+        <p:spPr>
+          <a:xfrm>
+            <a:off x="9326880" y="2286000"/>
+            <a:ext cx="365760" cy="365760"/>
+          </a:xfrm>
+          <a:prstGeom prst="rect">
+            <a:avLst/>
+          </a:prstGeom>
+          <a:noFill/>
+          <a:ln/>
+        </p:spPr>
+        <p:txBody>
+          <a:bodyPr wrap="square" rtlCol="0" anchor="ctr"/>
+          <a:lstStyle/>
+          <a:p>
+            <a:pPr algn="ctr" indent="0" marL="0">
+              <a:buNone/>
+            </a:pPr>
+            <a:r>
+              <a:rPr lang="en-US" sz="1300" b="1" dirty="0">
+                <a:solidFill>
+                  <a:srgbClr val="FFFFFF"/>
+                </a:solidFill>
+                <a:latin typeface="Georgia" pitchFamily="34" charset="0"/>
+                <a:ea typeface="Georgia" pitchFamily="34" charset="-122"/>
+                <a:cs typeface="Georgia" pitchFamily="34" charset="-120"/>
+              </a:rPr>
+              <a:t>4</a:t>
+            </a:r>
+            <a:endParaRPr lang="en-US" sz="1300" dirty="0"/>
+          </a:p>
+        </p:txBody>
+      </p:sp>
+      <p:sp>
+        <p:nvSpPr>
+          <p:cNvPr id="29" name="Shape 27"/>
+          <p:cNvSpPr/>
+          <p:nvPr/>
+        </p:nvSpPr>
+        <p:spPr>
+          <a:xfrm>
+            <a:off x="9006840" y="2926080"/>
+            <a:ext cx="2606040" cy="2651760"/>
+          </a:xfrm>
+          <a:prstGeom prst="rect">
+            <a:avLst/>
+          </a:prstGeom>
+          <a:solidFill>
+            <a:srgbClr val="FFFFFF"/>
+          </a:solidFill>
+          <a:ln w="12700">
+            <a:solidFill>
+              <a:srgbClr val="E4E6E1"/>
+            </a:solidFill>
+            <a:prstDash val="solid"/>
+          </a:ln>
+          <a:effectLst>
+            <a:outerShdw sx="100000" sy="100000" kx="0" ky="0" algn="bl" rotWithShape="0" blurRad="101600" dist="38100" dir="8100000">
+              <a:srgbClr val="000000">
+                <a:alpha val="12000"/>
+              </a:srgbClr>
+            </a:outerShdw>
+          </a:effectLst>
+        </p:spPr>
+      </p:sp>
+      <p:sp>
+        <p:nvSpPr>
+          <p:cNvPr id="30" name="Shape 28"/>
+          <p:cNvSpPr/>
+          <p:nvPr/>
+        </p:nvSpPr>
+        <p:spPr>
+          <a:xfrm>
+            <a:off x="9006840" y="2926080"/>
+            <a:ext cx="2606040" cy="109728"/>
+          </a:xfrm>
+          <a:prstGeom prst="rect">
+            <a:avLst/>
+          </a:prstGeom>
+          <a:solidFill>
+            <a:srgbClr val="093520"/>
+          </a:solidFill>
+          <a:ln/>
+        </p:spPr>
+      </p:sp>
+      <p:sp>
+        <p:nvSpPr>
+          <p:cNvPr id="31" name="Text 29"/>
+          <p:cNvSpPr/>
+          <p:nvPr/>
+        </p:nvSpPr>
+        <p:spPr>
+          <a:xfrm>
+            <a:off x="9208008" y="3127248"/>
+            <a:ext cx="2240280" cy="457200"/>
+          </a:xfrm>
+          <a:prstGeom prst="rect">
+            <a:avLst/>
+          </a:prstGeom>
+          <a:noFill/>
+          <a:ln/>
+        </p:spPr>
+        <p:txBody>
+          <a:bodyPr wrap="square" rtlCol="0" anchor="ctr"/>
+          <a:lstStyle/>
+          <a:p>
+            <a:pPr indent="0" marL="0">
+              <a:buNone/>
+            </a:pPr>
+            <a:r>
+              <a:rPr lang="en-US" sz="1600" b="1" dirty="0">
+                <a:solidFill>
+                  <a:srgbClr val="14160F"/>
+                </a:solidFill>
+                <a:latin typeface="Georgia" pitchFamily="34" charset="0"/>
+                <a:ea typeface="Georgia" pitchFamily="34" charset="-122"/>
+                <a:cs typeface="Georgia" pitchFamily="34" charset="-120"/>
+              </a:rPr>
+              <a:t>Масштаб B2B</a:t>
+            </a:r>
+            <a:endParaRPr lang="en-US" sz="1600" dirty="0"/>
+          </a:p>
+        </p:txBody>
+      </p:sp>
+      <p:sp>
+        <p:nvSpPr>
+          <p:cNvPr id="32" name="Text 30"/>
+          <p:cNvSpPr/>
+          <p:nvPr/>
+        </p:nvSpPr>
+        <p:spPr>
+          <a:xfrm>
+            <a:off x="9235440" y="3657600"/>
+            <a:ext cx="2194560" cy="1828800"/>
+          </a:xfrm>
+          <a:prstGeom prst="rect">
+            <a:avLst/>
+          </a:prstGeom>
+          <a:noFill/>
+          <a:ln/>
+        </p:spPr>
+        <p:txBody>
+          <a:bodyPr wrap="square" rtlCol="0" anchor="t"/>
+          <a:lstStyle/>
+          <a:p>
+            <a:pPr marL="342900" indent="-342900">
+              <a:spcAft>
+                <a:spcPts val="800"/>
+              </a:spcAft>
+              <a:buSzPct val="100000"/>
+              <a:buChar char="•"/>
+            </a:pPr>
+            <a:r>
+              <a:rPr lang="en-US" sz="1200" dirty="0">
+                <a:solidFill>
+                  <a:srgbClr val="717670"/>
+                </a:solidFill>
+                <a:latin typeface="Calibri" pitchFamily="34" charset="0"/>
+                <a:ea typeface="Calibri" pitchFamily="34" charset="-122"/>
+                <a:cs typeface="Calibri" pitchFamily="34" charset="-120"/>
+              </a:rPr>
+              <a:t>Подписка для школ и управлений образования</a:t>
+            </a:r>
+            <a:endParaRPr lang="en-US" sz="1200" dirty="0"/>
+          </a:p>
+          <a:p>
+            <a:pPr marL="342900" indent="-342900">
+              <a:spcAft>
+                <a:spcPts val="800"/>
+              </a:spcAft>
+              <a:buSzPct val="100000"/>
+              <a:buChar char="•"/>
+            </a:pPr>
+            <a:r>
+              <a:rPr lang="en-US" sz="1200" dirty="0">
+                <a:solidFill>
+                  <a:srgbClr val="717670"/>
+                </a:solidFill>
+                <a:latin typeface="Calibri" pitchFamily="34" charset="0"/>
+                <a:ea typeface="Calibri" pitchFamily="34" charset="-122"/>
+                <a:cs typeface="Calibri" pitchFamily="34" charset="-120"/>
+              </a:rPr>
+              <a:t>Интеграции с журналами · аналитика воспитания</a:t>
+            </a:r>
+            <a:endParaRPr lang="en-US" sz="1200" dirty="0"/>
+          </a:p>
+        </p:txBody>
+      </p:sp>
+      <p:sp>
+        <p:nvSpPr>
+          <p:cNvPr id="33" name="Text 31"/>
+          <p:cNvSpPr/>
+          <p:nvPr/>
+        </p:nvSpPr>
+        <p:spPr>
+          <a:xfrm>
+            <a:off x="640080" y="5852160"/>
+            <a:ext cx="10881360" cy="457200"/>
+          </a:xfrm>
+          <a:prstGeom prst="rect">
+            <a:avLst/>
+          </a:prstGeom>
+          <a:noFill/>
+          <a:ln/>
+        </p:spPr>
+        <p:txBody>
+          <a:bodyPr wrap="square" rtlCol="0" anchor="ctr"/>
+          <a:lstStyle/>
+          <a:p>
+            <a:pPr algn="ctr" indent="0" marL="0">
+              <a:buNone/>
+            </a:pPr>
+            <a:r>
+              <a:rPr lang="en-US" sz="1400" b="1" i="1" dirty="0">
+                <a:solidFill>
+                  <a:srgbClr val="21A663"/>
+                </a:solidFill>
+                <a:latin typeface="Calibri" pitchFamily="34" charset="0"/>
+                <a:ea typeface="Calibri" pitchFamily="34" charset="-122"/>
+                <a:cs typeface="Calibri" pitchFamily="34" charset="-120"/>
+              </a:rPr>
+              <a:t>Сейчас здесь →  MVP полностью реализован, идём к пилоту</a:t>
+            </a:r>
+            <a:endParaRPr lang="en-US" sz="1400" dirty="0"/>
+          </a:p>
+        </p:txBody>
+      </p:sp>
+    </p:spTree>
+  </p:cSld>
+  <p:clrMapOvr>
+    <a:masterClrMapping/>
+  </p:clrMapOvr>
+</p:sld>
+</file>
+
+<file path=ppt/slides/slide11.xml><?xml version="1.0" encoding="utf-8"?>
+<p:sld xmlns:a="http://schemas.openxmlformats.org/drawingml/2006/main" xmlns:r="http://schemas.openxmlformats.org/officeDocument/2006/relationships" xmlns:p="http://schemas.openxmlformats.org/presentationml/2006/main">
+  <p:cSld name="Slide 11">
+    <p:bg>
+      <p:bgPr>
+        <a:solidFill>
+          <a:srgbClr val="F8F9F7"/>
+        </a:solidFill>
+      </p:bgPr>
+    </p:bg>
+    <p:spTree>
+      <p:nvGrpSpPr>
+        <p:cNvPr id="1" name=""/>
+        <p:cNvGrpSpPr/>
+        <p:nvPr/>
+      </p:nvGrpSpPr>
+      <p:grpSpPr>
+        <a:xfrm>
+          <a:off x="0" y="0"/>
+          <a:ext cx="0" cy="0"/>
+          <a:chOff x="0" y="0"/>
+          <a:chExt cx="0" cy="0"/>
+        </a:xfrm>
+      </p:grpSpPr>
+      <p:sp>
+        <p:nvSpPr>
+          <p:cNvPr id="2" name="Shape 0"/>
+          <p:cNvSpPr/>
+          <p:nvPr/>
+        </p:nvSpPr>
+        <p:spPr>
+          <a:xfrm>
+            <a:off x="640080" y="566928"/>
+            <a:ext cx="310896" cy="310896"/>
+          </a:xfrm>
+          <a:prstGeom prst="rect">
+            <a:avLst/>
+          </a:prstGeom>
+          <a:solidFill>
+            <a:srgbClr val="F5B800"/>
+          </a:solidFill>
+          <a:ln/>
+        </p:spPr>
+      </p:sp>
+      <p:sp>
+        <p:nvSpPr>
+          <p:cNvPr id="3" name="Text 1"/>
+          <p:cNvSpPr/>
+          <p:nvPr/>
+        </p:nvSpPr>
+        <p:spPr>
+          <a:xfrm>
+            <a:off x="1060704" y="457200"/>
+            <a:ext cx="8229600" cy="502920"/>
+          </a:xfrm>
+          <a:prstGeom prst="rect">
+            <a:avLst/>
+          </a:prstGeom>
+          <a:noFill/>
+          <a:ln/>
+        </p:spPr>
+        <p:txBody>
+          <a:bodyPr wrap="square" rtlCol="0" anchor="ctr"/>
+          <a:lstStyle/>
+          <a:p>
+            <a:pPr indent="0" marL="0">
+              <a:buNone/>
+            </a:pPr>
+            <a:r>
+              <a:rPr lang="en-US" sz="1300" b="1" spc="200" kern="0" dirty="0">
+                <a:solidFill>
+                  <a:srgbClr val="21A663"/>
+                </a:solidFill>
+                <a:latin typeface="Calibri" pitchFamily="34" charset="0"/>
+                <a:ea typeface="Calibri" pitchFamily="34" charset="-122"/>
+                <a:cs typeface="Calibri" pitchFamily="34" charset="-120"/>
+              </a:rPr>
+              <a:t>08 — РИСКИ</a:t>
+            </a:r>
+            <a:endParaRPr lang="en-US" sz="1300" dirty="0"/>
+          </a:p>
+        </p:txBody>
+      </p:sp>
+      <p:sp>
+        <p:nvSpPr>
+          <p:cNvPr id="4" name="Text 2"/>
+          <p:cNvSpPr/>
+          <p:nvPr/>
+        </p:nvSpPr>
+        <p:spPr>
+          <a:xfrm>
+            <a:off x="640080" y="868680"/>
+            <a:ext cx="10881360" cy="868680"/>
+          </a:xfrm>
+          <a:prstGeom prst="rect">
+            <a:avLst/>
+          </a:prstGeom>
+          <a:noFill/>
+          <a:ln/>
+        </p:spPr>
+        <p:txBody>
+          <a:bodyPr wrap="square" rtlCol="0" anchor="ctr"/>
+          <a:lstStyle/>
+          <a:p>
+            <a:pPr indent="0" marL="0">
+              <a:buNone/>
+            </a:pPr>
+            <a:r>
+              <a:rPr lang="en-US" sz="3200" b="1" dirty="0">
+                <a:solidFill>
+                  <a:srgbClr val="14160F"/>
+                </a:solidFill>
+                <a:latin typeface="Georgia" pitchFamily="34" charset="0"/>
+                <a:ea typeface="Georgia" pitchFamily="34" charset="-122"/>
+                <a:cs typeface="Georgia" pitchFamily="34" charset="-120"/>
+              </a:rPr>
               <a:t>Риски и их нейтрализация</a:t>
             </a:r>
             <a:endParaRPr lang="en-US" sz="3200" dirty="0"/>
@@ -2481,7 +3726,7 @@
       </p:sp>
       <p:graphicFrame>
         <p:nvGraphicFramePr>
-          <p:cNvPr id="11" name="Table 0"/>
+          <p:cNvPr id="12" name="Table 0"/>
           <p:cNvGraphicFramePr>
             <a:graphicFrameLocks noGrp="1"/>
           </p:cNvGraphicFramePr>
@@ -3998,9 +5243,9 @@
 </p:sld>
 </file>
 
-<file path=ppt/slides/slide11.xml><?xml version="1.0" encoding="utf-8"?>
+<file path=ppt/slides/slide12.xml><?xml version="1.0" encoding="utf-8"?>
 <p:sld xmlns:a="http://schemas.openxmlformats.org/drawingml/2006/main" xmlns:r="http://schemas.openxmlformats.org/officeDocument/2006/relationships" xmlns:p="http://schemas.openxmlformats.org/presentationml/2006/main">
-  <p:cSld name="Slide 11">
+  <p:cSld name="Slide 12">
     <p:bg>
       <p:bgPr>
         <a:solidFill>
@@ -4874,9 +6119,9 @@
 </p:sld>
 </file>
 
-<file path=ppt/slides/slide12.xml><?xml version="1.0" encoding="utf-8"?>
+<file path=ppt/slides/slide13.xml><?xml version="1.0" encoding="utf-8"?>
 <p:sld xmlns:a="http://schemas.openxmlformats.org/drawingml/2006/main" xmlns:r="http://schemas.openxmlformats.org/officeDocument/2006/relationships" xmlns:p="http://schemas.openxmlformats.org/presentationml/2006/main">
-  <p:cSld name="Slide 12">
+  <p:cSld name="Slide 13">
     <p:bg>
       <p:bgPr>
         <a:solidFill>
@@ -5525,9 +6770,9 @@
 </p:sld>
 </file>
 
-<file path=ppt/slides/slide13.xml><?xml version="1.0" encoding="utf-8"?>
+<file path=ppt/slides/slide14.xml><?xml version="1.0" encoding="utf-8"?>
 <p:sld xmlns:a="http://schemas.openxmlformats.org/drawingml/2006/main" xmlns:r="http://schemas.openxmlformats.org/officeDocument/2006/relationships" xmlns:p="http://schemas.openxmlformats.org/presentationml/2006/main">
-  <p:cSld name="Slide 13">
+  <p:cSld name="Slide 14">
     <p:bg>
       <p:bgPr>
         <a:solidFill>
@@ -16008,7 +17253,7 @@
                 <a:ea typeface="Calibri" pitchFamily="34" charset="-122"/>
                 <a:cs typeface="Calibri" pitchFamily="34" charset="-120"/>
               </a:rPr>
-              <a:t>06 — MVP</a:t>
+              <a:t>06 — MVP · ДЕМО-ПУТЬ 1/2</a:t>
             </a:r>
             <a:endParaRPr lang="en-US" sz="1300" dirty="0"/>
           </a:p>
@@ -16047,7 +17292,7 @@
                 <a:ea typeface="Georgia" pitchFamily="34" charset="-122"/>
                 <a:cs typeface="Georgia" pitchFamily="34" charset="-120"/>
               </a:rPr>
-              <a:t>Рабочая версия: полный путь без заглушек</a:t>
+              <a:t>Контекст → стрим генерации</a:t>
             </a:r>
             <a:endParaRPr lang="en-US" sz="3200" dirty="0"/>
           </a:p>
@@ -16055,53 +17300,14 @@
       </p:sp>
       <p:sp>
         <p:nvSpPr>
-          <p:cNvPr id="5" name="Text 3"/>
-          <p:cNvSpPr/>
-          <p:nvPr/>
-        </p:nvSpPr>
-        <p:spPr>
-          <a:xfrm>
-            <a:off x="640080" y="1874520"/>
-            <a:ext cx="5486400" cy="365760"/>
-          </a:xfrm>
-          <a:prstGeom prst="rect">
-            <a:avLst/>
-          </a:prstGeom>
-          <a:noFill/>
-          <a:ln/>
-        </p:spPr>
-        <p:txBody>
-          <a:bodyPr wrap="square" rtlCol="0" anchor="ctr"/>
-          <a:lstStyle/>
-          <a:p>
-            <a:pPr indent="0" marL="0">
-              <a:buNone/>
-            </a:pPr>
-            <a:r>
-              <a:rPr lang="en-US" sz="1400" b="1" dirty="0">
-                <a:solidFill>
-                  <a:srgbClr val="14160F"/>
-                </a:solidFill>
-                <a:latin typeface="Georgia" pitchFamily="34" charset="0"/>
-                <a:ea typeface="Georgia" pitchFamily="34" charset="-122"/>
-                <a:cs typeface="Georgia" pitchFamily="34" charset="-120"/>
-              </a:rPr>
-              <a:t>Демо-путь: контекст → стрим → редактор → экспорт</a:t>
-            </a:r>
-            <a:endParaRPr lang="en-US" sz="1400" dirty="0"/>
-          </a:p>
-        </p:txBody>
-      </p:sp>
-      <p:sp>
-        <p:nvSpPr>
-          <p:cNvPr id="6" name="Shape 4"/>
-          <p:cNvSpPr/>
-          <p:nvPr/>
-        </p:nvSpPr>
-        <p:spPr>
-          <a:xfrm>
-            <a:off x="640080" y="2331720"/>
-            <a:ext cx="2514600" cy="1965960"/>
+          <p:cNvPr id="5" name="Shape 3"/>
+          <p:cNvSpPr/>
+          <p:nvPr/>
+        </p:nvSpPr>
+        <p:spPr>
+          <a:xfrm>
+            <a:off x="502920" y="1874520"/>
+            <a:ext cx="5532120" cy="3703320"/>
           </a:xfrm>
           <a:prstGeom prst="rect">
             <a:avLst/>
@@ -16126,7 +17332,7 @@
       </p:sp>
       <p:pic>
         <p:nvPicPr>
-          <p:cNvPr id="7" name="Image 0" descr="/home/nikit/planwise/artifacts/1-form.png">    </p:cNvPr>
+          <p:cNvPr id="6" name="Image 0" descr="/home/nikit/planwise/artifacts/1-form.png">    </p:cNvPr>
           <p:cNvPicPr>
             <a:picLocks noChangeAspect="1"/>
           </p:cNvPicPr>
@@ -16139,8 +17345,8 @@
         </p:blipFill>
         <p:spPr>
           <a:xfrm>
-            <a:off x="713232" y="2404872"/>
-            <a:ext cx="2368296" cy="1517904"/>
+            <a:off x="594360" y="1965960"/>
+            <a:ext cx="5349240" cy="3108960"/>
           </a:xfrm>
           <a:prstGeom prst="rect">
             <a:avLst/>
@@ -16149,14 +17355,14 @@
       </p:pic>
       <p:sp>
         <p:nvSpPr>
-          <p:cNvPr id="8" name="Shape 5"/>
-          <p:cNvSpPr/>
-          <p:nvPr/>
-        </p:nvSpPr>
-        <p:spPr>
-          <a:xfrm>
-            <a:off x="640080" y="3922776"/>
-            <a:ext cx="2514600" cy="374904"/>
+          <p:cNvPr id="7" name="Shape 4"/>
+          <p:cNvSpPr/>
+          <p:nvPr/>
+        </p:nvSpPr>
+        <p:spPr>
+          <a:xfrm>
+            <a:off x="502920" y="5166360"/>
+            <a:ext cx="5532120" cy="411480"/>
           </a:xfrm>
           <a:prstGeom prst="rect">
             <a:avLst/>
@@ -16169,14 +17375,14 @@
       </p:sp>
       <p:sp>
         <p:nvSpPr>
-          <p:cNvPr id="9" name="Text 6"/>
-          <p:cNvSpPr/>
-          <p:nvPr/>
-        </p:nvSpPr>
-        <p:spPr>
-          <a:xfrm>
-            <a:off x="749808" y="3922776"/>
-            <a:ext cx="2295144" cy="374904"/>
+          <p:cNvPr id="8" name="Text 5"/>
+          <p:cNvSpPr/>
+          <p:nvPr/>
+        </p:nvSpPr>
+        <p:spPr>
+          <a:xfrm>
+            <a:off x="667512" y="5166360"/>
+            <a:ext cx="5202936" cy="411480"/>
           </a:xfrm>
           <a:prstGeom prst="rect">
             <a:avLst/>
@@ -16192,7 +17398,7 @@
               <a:buNone/>
             </a:pPr>
             <a:r>
-              <a:rPr lang="en-US" sz="1150" b="1" dirty="0">
+              <a:rPr lang="en-US" sz="1300" b="1" dirty="0">
                 <a:solidFill>
                   <a:srgbClr val="FFFFFF"/>
                 </a:solidFill>
@@ -16200,22 +17406,22 @@
                 <a:ea typeface="Calibri" pitchFamily="34" charset="-122"/>
                 <a:cs typeface="Calibri" pitchFamily="34" charset="-120"/>
               </a:rPr>
-              <a:t>1. Форма контекста</a:t>
-            </a:r>
-            <a:endParaRPr lang="en-US" sz="1150" dirty="0"/>
-          </a:p>
-        </p:txBody>
-      </p:sp>
-      <p:sp>
-        <p:nvSpPr>
-          <p:cNvPr id="10" name="Shape 7"/>
-          <p:cNvSpPr/>
-          <p:nvPr/>
-        </p:nvSpPr>
-        <p:spPr>
-          <a:xfrm>
-            <a:off x="3246120" y="2331720"/>
-            <a:ext cx="2514600" cy="1965960"/>
+              <a:t>1. Форма контекста — тема, класс, формат, длительность</a:t>
+            </a:r>
+            <a:endParaRPr lang="en-US" sz="1300" dirty="0"/>
+          </a:p>
+        </p:txBody>
+      </p:sp>
+      <p:sp>
+        <p:nvSpPr>
+          <p:cNvPr id="9" name="Shape 6"/>
+          <p:cNvSpPr/>
+          <p:nvPr/>
+        </p:nvSpPr>
+        <p:spPr>
+          <a:xfrm>
+            <a:off x="6172200" y="1874520"/>
+            <a:ext cx="5532120" cy="3703320"/>
           </a:xfrm>
           <a:prstGeom prst="rect">
             <a:avLst/>
@@ -16240,7 +17446,7 @@
       </p:sp>
       <p:pic>
         <p:nvPicPr>
-          <p:cNvPr id="11" name="Image 1" descr="/home/nikit/planwise/artifacts/2-stream.png">    </p:cNvPr>
+          <p:cNvPr id="10" name="Image 1" descr="/home/nikit/planwise/artifacts/2-stream.png">    </p:cNvPr>
           <p:cNvPicPr>
             <a:picLocks noChangeAspect="1"/>
           </p:cNvPicPr>
@@ -16253,8 +17459,8 @@
         </p:blipFill>
         <p:spPr>
           <a:xfrm>
-            <a:off x="3319272" y="2404872"/>
-            <a:ext cx="2368296" cy="1517904"/>
+            <a:off x="6263640" y="1965960"/>
+            <a:ext cx="5349240" cy="3108960"/>
           </a:xfrm>
           <a:prstGeom prst="rect">
             <a:avLst/>
@@ -16263,14 +17469,14 @@
       </p:pic>
       <p:sp>
         <p:nvSpPr>
-          <p:cNvPr id="12" name="Shape 8"/>
-          <p:cNvSpPr/>
-          <p:nvPr/>
-        </p:nvSpPr>
-        <p:spPr>
-          <a:xfrm>
-            <a:off x="3246120" y="3922776"/>
-            <a:ext cx="2514600" cy="374904"/>
+          <p:cNvPr id="11" name="Shape 7"/>
+          <p:cNvSpPr/>
+          <p:nvPr/>
+        </p:nvSpPr>
+        <p:spPr>
+          <a:xfrm>
+            <a:off x="6172200" y="5166360"/>
+            <a:ext cx="5532120" cy="411480"/>
           </a:xfrm>
           <a:prstGeom prst="rect">
             <a:avLst/>
@@ -16283,14 +17489,14 @@
       </p:sp>
       <p:sp>
         <p:nvSpPr>
-          <p:cNvPr id="13" name="Text 9"/>
-          <p:cNvSpPr/>
-          <p:nvPr/>
-        </p:nvSpPr>
-        <p:spPr>
-          <a:xfrm>
-            <a:off x="3355848" y="3922776"/>
-            <a:ext cx="2295144" cy="374904"/>
+          <p:cNvPr id="12" name="Text 8"/>
+          <p:cNvSpPr/>
+          <p:nvPr/>
+        </p:nvSpPr>
+        <p:spPr>
+          <a:xfrm>
+            <a:off x="6336792" y="5166360"/>
+            <a:ext cx="5202936" cy="411480"/>
           </a:xfrm>
           <a:prstGeom prst="rect">
             <a:avLst/>
@@ -16306,7 +17512,7 @@
               <a:buNone/>
             </a:pPr>
             <a:r>
-              <a:rPr lang="en-US" sz="1150" b="1" dirty="0">
+              <a:rPr lang="en-US" sz="1300" b="1" dirty="0">
                 <a:solidFill>
                   <a:srgbClr val="FFFFFF"/>
                 </a:solidFill>
@@ -16314,662 +17520,22 @@
                 <a:ea typeface="Calibri" pitchFamily="34" charset="-122"/>
                 <a:cs typeface="Calibri" pitchFamily="34" charset="-120"/>
               </a:rPr>
-              <a:t>2. Стрим генерации по блокам</a:t>
-            </a:r>
-            <a:endParaRPr lang="en-US" sz="1150" dirty="0"/>
-          </a:p>
-        </p:txBody>
-      </p:sp>
-      <p:sp>
-        <p:nvSpPr>
-          <p:cNvPr id="14" name="Shape 10"/>
-          <p:cNvSpPr/>
-          <p:nvPr/>
-        </p:nvSpPr>
-        <p:spPr>
-          <a:xfrm>
-            <a:off x="640080" y="4389120"/>
-            <a:ext cx="2514600" cy="1965960"/>
-          </a:xfrm>
-          <a:prstGeom prst="rect">
-            <a:avLst/>
-          </a:prstGeom>
-          <a:solidFill>
-            <a:srgbClr val="FFFFFF"/>
-          </a:solidFill>
-          <a:ln w="12700">
-            <a:solidFill>
-              <a:srgbClr val="E4E6E1"/>
-            </a:solidFill>
-            <a:prstDash val="solid"/>
-          </a:ln>
-          <a:effectLst>
-            <a:outerShdw sx="100000" sy="100000" kx="0" ky="0" algn="bl" rotWithShape="0" blurRad="101600" dist="38100" dir="8100000">
-              <a:srgbClr val="000000">
-                <a:alpha val="12000"/>
-              </a:srgbClr>
-            </a:outerShdw>
-          </a:effectLst>
-        </p:spPr>
-      </p:sp>
-      <p:pic>
-        <p:nvPicPr>
-          <p:cNvPr id="15" name="Image 2" descr="/home/nikit/planwise/artifacts/5-editor-regen.png">    </p:cNvPr>
-          <p:cNvPicPr>
-            <a:picLocks noChangeAspect="1"/>
-          </p:cNvPicPr>
-          <p:nvPr/>
-        </p:nvPicPr>
-        <p:blipFill>
-          <a:blip r:embed="rId3"/>
-          <a:srcRect l="0" r="0" t="0" b="0"/>
-          <a:stretch/>
-        </p:blipFill>
-        <p:spPr>
-          <a:xfrm>
-            <a:off x="713232" y="4462272"/>
-            <a:ext cx="2368296" cy="1517904"/>
-          </a:xfrm>
-          <a:prstGeom prst="rect">
-            <a:avLst/>
-          </a:prstGeom>
-        </p:spPr>
-      </p:pic>
-      <p:sp>
-        <p:nvSpPr>
-          <p:cNvPr id="16" name="Shape 11"/>
-          <p:cNvSpPr/>
-          <p:nvPr/>
-        </p:nvSpPr>
-        <p:spPr>
-          <a:xfrm>
-            <a:off x="640080" y="5980176"/>
-            <a:ext cx="2514600" cy="374904"/>
-          </a:xfrm>
-          <a:prstGeom prst="rect">
-            <a:avLst/>
-          </a:prstGeom>
-          <a:solidFill>
-            <a:srgbClr val="0E4F30"/>
-          </a:solidFill>
-          <a:ln/>
-        </p:spPr>
-      </p:sp>
-      <p:sp>
-        <p:nvSpPr>
-          <p:cNvPr id="17" name="Text 12"/>
-          <p:cNvSpPr/>
-          <p:nvPr/>
-        </p:nvSpPr>
-        <p:spPr>
-          <a:xfrm>
-            <a:off x="749808" y="5980176"/>
-            <a:ext cx="2295144" cy="374904"/>
-          </a:xfrm>
-          <a:prstGeom prst="rect">
-            <a:avLst/>
-          </a:prstGeom>
-          <a:noFill/>
-          <a:ln/>
-        </p:spPr>
-        <p:txBody>
-          <a:bodyPr wrap="square" rtlCol="0" anchor="ctr"/>
-          <a:lstStyle/>
-          <a:p>
-            <a:pPr indent="0" marL="0">
-              <a:buNone/>
-            </a:pPr>
-            <a:r>
-              <a:rPr lang="en-US" sz="1150" b="1" dirty="0">
-                <a:solidFill>
-                  <a:srgbClr val="FFFFFF"/>
-                </a:solidFill>
-                <a:latin typeface="Calibri" pitchFamily="34" charset="0"/>
-                <a:ea typeface="Calibri" pitchFamily="34" charset="-122"/>
-                <a:cs typeface="Calibri" pitchFamily="34" charset="-120"/>
-              </a:rPr>
-              <a:t>3. Редактор: 🎲 · ↑↓ · add/del</a:t>
-            </a:r>
-            <a:endParaRPr lang="en-US" sz="1150" dirty="0"/>
-          </a:p>
-        </p:txBody>
-      </p:sp>
-      <p:sp>
-        <p:nvSpPr>
-          <p:cNvPr id="18" name="Shape 13"/>
-          <p:cNvSpPr/>
-          <p:nvPr/>
-        </p:nvSpPr>
-        <p:spPr>
-          <a:xfrm>
-            <a:off x="3246120" y="4389120"/>
-            <a:ext cx="2514600" cy="1965960"/>
-          </a:xfrm>
-          <a:prstGeom prst="rect">
-            <a:avLst/>
-          </a:prstGeom>
-          <a:solidFill>
-            <a:srgbClr val="FFFFFF"/>
-          </a:solidFill>
-          <a:ln w="12700">
-            <a:solidFill>
-              <a:srgbClr val="E4E6E1"/>
-            </a:solidFill>
-            <a:prstDash val="solid"/>
-          </a:ln>
-          <a:effectLst>
-            <a:outerShdw sx="100000" sy="100000" kx="0" ky="0" algn="bl" rotWithShape="0" blurRad="101600" dist="38100" dir="8100000">
-              <a:srgbClr val="000000">
-                <a:alpha val="12000"/>
-              </a:srgbClr>
-            </a:outerShdw>
-          </a:effectLst>
-        </p:spPr>
-      </p:sp>
-      <p:pic>
-        <p:nvPicPr>
-          <p:cNvPr id="19" name="Image 3" descr="/home/nikit/planwise/artifacts/4-export.png">    </p:cNvPr>
-          <p:cNvPicPr>
-            <a:picLocks noChangeAspect="1"/>
-          </p:cNvPicPr>
-          <p:nvPr/>
-        </p:nvPicPr>
-        <p:blipFill>
-          <a:blip r:embed="rId4"/>
-          <a:srcRect l="0" r="0" t="0" b="0"/>
-          <a:stretch/>
-        </p:blipFill>
-        <p:spPr>
-          <a:xfrm>
-            <a:off x="3319272" y="4462272"/>
-            <a:ext cx="2368296" cy="1517904"/>
-          </a:xfrm>
-          <a:prstGeom prst="rect">
-            <a:avLst/>
-          </a:prstGeom>
-        </p:spPr>
-      </p:pic>
-      <p:sp>
-        <p:nvSpPr>
-          <p:cNvPr id="20" name="Shape 14"/>
-          <p:cNvSpPr/>
-          <p:nvPr/>
-        </p:nvSpPr>
-        <p:spPr>
-          <a:xfrm>
-            <a:off x="3246120" y="5980176"/>
-            <a:ext cx="2514600" cy="374904"/>
-          </a:xfrm>
-          <a:prstGeom prst="rect">
-            <a:avLst/>
-          </a:prstGeom>
-          <a:solidFill>
-            <a:srgbClr val="0E4F30"/>
-          </a:solidFill>
-          <a:ln/>
-        </p:spPr>
-      </p:sp>
-      <p:sp>
-        <p:nvSpPr>
-          <p:cNvPr id="21" name="Text 15"/>
-          <p:cNvSpPr/>
-          <p:nvPr/>
-        </p:nvSpPr>
-        <p:spPr>
-          <a:xfrm>
-            <a:off x="3355848" y="5980176"/>
-            <a:ext cx="2295144" cy="374904"/>
-          </a:xfrm>
-          <a:prstGeom prst="rect">
-            <a:avLst/>
-          </a:prstGeom>
-          <a:noFill/>
-          <a:ln/>
-        </p:spPr>
-        <p:txBody>
-          <a:bodyPr wrap="square" rtlCol="0" anchor="ctr"/>
-          <a:lstStyle/>
-          <a:p>
-            <a:pPr indent="0" marL="0">
-              <a:buNone/>
-            </a:pPr>
-            <a:r>
-              <a:rPr lang="en-US" sz="1150" b="1" dirty="0">
-                <a:solidFill>
-                  <a:srgbClr val="FFFFFF"/>
-                </a:solidFill>
-                <a:latin typeface="Calibri" pitchFamily="34" charset="0"/>
-                <a:ea typeface="Calibri" pitchFamily="34" charset="-122"/>
-                <a:cs typeface="Calibri" pitchFamily="34" charset="-120"/>
-              </a:rPr>
-              <a:t>4. Экспорт PDF / DOCX</a:t>
-            </a:r>
-            <a:endParaRPr lang="en-US" sz="1150" dirty="0"/>
-          </a:p>
-        </p:txBody>
-      </p:sp>
-      <p:sp>
-        <p:nvSpPr>
-          <p:cNvPr id="22" name="Shape 16"/>
-          <p:cNvSpPr/>
-          <p:nvPr/>
-        </p:nvSpPr>
-        <p:spPr>
-          <a:xfrm>
-            <a:off x="6126480" y="1874520"/>
-            <a:ext cx="5394960" cy="2606040"/>
-          </a:xfrm>
-          <a:prstGeom prst="rect">
-            <a:avLst/>
-          </a:prstGeom>
-          <a:solidFill>
-            <a:srgbClr val="FFFFFF"/>
-          </a:solidFill>
-          <a:ln w="12700">
-            <a:solidFill>
-              <a:srgbClr val="E4E6E1"/>
-            </a:solidFill>
-            <a:prstDash val="solid"/>
-          </a:ln>
-          <a:effectLst>
-            <a:outerShdw sx="100000" sy="100000" kx="0" ky="0" algn="bl" rotWithShape="0" blurRad="101600" dist="38100" dir="8100000">
-              <a:srgbClr val="000000">
-                <a:alpha val="12000"/>
-              </a:srgbClr>
-            </a:outerShdw>
-          </a:effectLst>
-        </p:spPr>
-      </p:sp>
-      <p:sp>
-        <p:nvSpPr>
-          <p:cNvPr id="23" name="Text 17"/>
-          <p:cNvSpPr/>
-          <p:nvPr/>
-        </p:nvSpPr>
-        <p:spPr>
-          <a:xfrm>
-            <a:off x="6355080" y="2011680"/>
-            <a:ext cx="4937760" cy="411480"/>
-          </a:xfrm>
-          <a:prstGeom prst="rect">
-            <a:avLst/>
-          </a:prstGeom>
-          <a:noFill/>
-          <a:ln/>
-        </p:spPr>
-        <p:txBody>
-          <a:bodyPr wrap="square" rtlCol="0" anchor="ctr"/>
-          <a:lstStyle/>
-          <a:p>
-            <a:pPr indent="0" marL="0">
-              <a:buNone/>
-            </a:pPr>
-            <a:r>
-              <a:rPr lang="en-US" sz="1600" b="1" dirty="0">
-                <a:solidFill>
-                  <a:srgbClr val="21A663"/>
-                </a:solidFill>
-                <a:latin typeface="Georgia" pitchFamily="34" charset="0"/>
-                <a:ea typeface="Georgia" pitchFamily="34" charset="-122"/>
-                <a:cs typeface="Georgia" pitchFamily="34" charset="-120"/>
-              </a:rPr>
-              <a:t>Что уже работает</a:t>
-            </a:r>
-            <a:endParaRPr lang="en-US" sz="1600" dirty="0"/>
-          </a:p>
-        </p:txBody>
-      </p:sp>
-      <p:sp>
-        <p:nvSpPr>
-          <p:cNvPr id="24" name="Text 18"/>
-          <p:cNvSpPr/>
-          <p:nvPr/>
-        </p:nvSpPr>
-        <p:spPr>
-          <a:xfrm>
-            <a:off x="6400800" y="2468880"/>
-            <a:ext cx="5029200" cy="1920240"/>
-          </a:xfrm>
-          <a:prstGeom prst="rect">
-            <a:avLst/>
-          </a:prstGeom>
-          <a:noFill/>
-          <a:ln/>
-        </p:spPr>
-        <p:txBody>
-          <a:bodyPr wrap="square" rtlCol="0" anchor="t"/>
-          <a:lstStyle/>
-          <a:p>
-            <a:pPr marL="342900" indent="-342900">
-              <a:spcAft>
-                <a:spcPts val="400"/>
-              </a:spcAft>
-              <a:buSzPct val="100000"/>
-              <a:buChar char="✓"/>
-            </a:pPr>
-            <a:r>
-              <a:rPr lang="en-US" sz="1150" dirty="0">
-                <a:solidFill>
-                  <a:srgbClr val="14160F"/>
-                </a:solidFill>
-                <a:latin typeface="Calibri" pitchFamily="34" charset="0"/>
-                <a:ea typeface="Calibri" pitchFamily="34" charset="-122"/>
-                <a:cs typeface="Calibri" pitchFamily="34" charset="-120"/>
-              </a:rPr>
-              <a:t>Генерация по блокам РоВ-уровня во всех 8 форматах (классный час, квиз, дебаты, киноклуб, проектная сессия…)</a:t>
-            </a:r>
-            <a:endParaRPr lang="en-US" sz="1150" dirty="0"/>
-          </a:p>
-          <a:p>
-            <a:pPr marL="342900" indent="-342900">
-              <a:spcAft>
-                <a:spcPts val="400"/>
-              </a:spcAft>
-              <a:buSzPct val="100000"/>
-              <a:buChar char="✓"/>
-            </a:pPr>
-            <a:r>
-              <a:rPr lang="en-US" sz="1150" dirty="0">
-                <a:solidFill>
-                  <a:srgbClr val="14160F"/>
-                </a:solidFill>
-                <a:latin typeface="Calibri" pitchFamily="34" charset="0"/>
-                <a:ea typeface="Calibri" pitchFamily="34" charset="-122"/>
-                <a:cs typeface="Calibri" pitchFamily="34" charset="-120"/>
-              </a:rPr>
-              <a:t>Загрузка плана и своего материала (PDF/DOCX/PPTX/TXT) как основы сценария</a:t>
-            </a:r>
-            <a:endParaRPr lang="en-US" sz="1150" dirty="0"/>
-          </a:p>
-          <a:p>
-            <a:pPr marL="342900" indent="-342900">
-              <a:spcAft>
-                <a:spcPts val="400"/>
-              </a:spcAft>
-              <a:buSzPct val="100000"/>
-              <a:buChar char="✓"/>
-            </a:pPr>
-            <a:r>
-              <a:rPr lang="en-US" sz="1150" dirty="0">
-                <a:solidFill>
-                  <a:srgbClr val="14160F"/>
-                </a:solidFill>
-                <a:latin typeface="Calibri" pitchFamily="34" charset="0"/>
-                <a:ea typeface="Calibri" pitchFamily="34" charset="-122"/>
-                <a:cs typeface="Calibri" pitchFamily="34" charset="-120"/>
-              </a:rPr>
-              <a:t>Редактор: добавление/удаление и reorder этапов ↑/↓, точечная регенерация с выбором типа, история версий с откатом</a:t>
-            </a:r>
-            <a:endParaRPr lang="en-US" sz="1150" dirty="0"/>
-          </a:p>
-          <a:p>
-            <a:pPr marL="342900" indent="-342900">
-              <a:spcAft>
-                <a:spcPts val="400"/>
-              </a:spcAft>
-              <a:buSzPct val="100000"/>
-              <a:buChar char="✓"/>
-            </a:pPr>
-            <a:r>
-              <a:rPr lang="en-US" sz="1150" dirty="0">
-                <a:solidFill>
-                  <a:srgbClr val="14160F"/>
-                </a:solidFill>
-                <a:latin typeface="Calibri" pitchFamily="34" charset="0"/>
-                <a:ea typeface="Calibri" pitchFamily="34" charset="-122"/>
-                <a:cs typeface="Calibri" pitchFamily="34" charset="-120"/>
-              </a:rPr>
-              <a:t>Полноэкранный режим показа на проекторе + календарь-сетка с привязкой к дате</a:t>
-            </a:r>
-            <a:endParaRPr lang="en-US" sz="1150" dirty="0"/>
-          </a:p>
-          <a:p>
-            <a:pPr marL="342900" indent="-342900">
-              <a:spcAft>
-                <a:spcPts val="400"/>
-              </a:spcAft>
-              <a:buSzPct val="100000"/>
-              <a:buChar char="✓"/>
-            </a:pPr>
-            <a:r>
-              <a:rPr lang="en-US" sz="1150" dirty="0">
-                <a:solidFill>
-                  <a:srgbClr val="14160F"/>
-                </a:solidFill>
-                <a:latin typeface="Calibri" pitchFamily="34" charset="0"/>
-                <a:ea typeface="Calibri" pitchFamily="34" charset="-122"/>
-                <a:cs typeface="Calibri" pitchFamily="34" charset="-120"/>
-              </a:rPr>
-              <a:t>Библиотека сообщества + семантический поиск, оценка сценария 👍/👎</a:t>
-            </a:r>
-            <a:endParaRPr lang="en-US" sz="1150" dirty="0"/>
-          </a:p>
-          <a:p>
-            <a:pPr marL="342900" indent="-342900">
-              <a:spcAft>
-                <a:spcPts val="400"/>
-              </a:spcAft>
-              <a:buSzPct val="100000"/>
-              <a:buChar char="✓"/>
-            </a:pPr>
-            <a:r>
-              <a:rPr lang="en-US" sz="1150" dirty="0">
-                <a:solidFill>
-                  <a:srgbClr val="14160F"/>
-                </a:solidFill>
-                <a:latin typeface="Calibri" pitchFamily="34" charset="0"/>
-                <a:ea typeface="Calibri" pitchFamily="34" charset="-122"/>
-                <a:cs typeface="Calibri" pitchFamily="34" charset="-120"/>
-              </a:rPr>
-              <a:t>Фирменный экспорт PDF (с QR) и DOCX · шаринг по ссылке · страница «Что нового»</a:t>
-            </a:r>
-            <a:endParaRPr lang="en-US" sz="1150" dirty="0"/>
-          </a:p>
-          <a:p>
-            <a:pPr marL="342900" indent="-342900">
-              <a:spcAft>
-                <a:spcPts val="400"/>
-              </a:spcAft>
-              <a:buSzPct val="100000"/>
-              <a:buChar char="✓"/>
-            </a:pPr>
-            <a:r>
-              <a:rPr lang="en-US" sz="1150" dirty="0">
-                <a:solidFill>
-                  <a:srgbClr val="14160F"/>
-                </a:solidFill>
-                <a:latin typeface="Calibri" pitchFamily="34" charset="0"/>
-                <a:ea typeface="Calibri" pitchFamily="34" charset="-122"/>
-                <a:cs typeface="Calibri" pitchFamily="34" charset="-120"/>
-              </a:rPr>
-              <a:t>Админ-панель статистики</a:t>
-            </a:r>
-            <a:endParaRPr lang="en-US" sz="1150" dirty="0"/>
-          </a:p>
-        </p:txBody>
-      </p:sp>
-      <p:sp>
-        <p:nvSpPr>
-          <p:cNvPr id="25" name="Shape 19"/>
-          <p:cNvSpPr/>
-          <p:nvPr/>
-        </p:nvSpPr>
-        <p:spPr>
-          <a:xfrm>
-            <a:off x="6126480" y="4617720"/>
-            <a:ext cx="2606040" cy="1783080"/>
-          </a:xfrm>
-          <a:prstGeom prst="rect">
-            <a:avLst/>
-          </a:prstGeom>
-          <a:solidFill>
-            <a:srgbClr val="093520"/>
-          </a:solidFill>
-          <a:ln/>
-          <a:effectLst>
-            <a:outerShdw sx="100000" sy="100000" kx="0" ky="0" algn="bl" rotWithShape="0" blurRad="101600" dist="38100" dir="8100000">
-              <a:srgbClr val="000000">
-                <a:alpha val="12000"/>
-              </a:srgbClr>
-            </a:outerShdw>
-          </a:effectLst>
-        </p:spPr>
-      </p:sp>
-      <p:sp>
-        <p:nvSpPr>
-          <p:cNvPr id="26" name="Text 20"/>
-          <p:cNvSpPr/>
-          <p:nvPr/>
-        </p:nvSpPr>
-        <p:spPr>
-          <a:xfrm>
-            <a:off x="6309360" y="4754880"/>
-            <a:ext cx="2286000" cy="365760"/>
-          </a:xfrm>
-          <a:prstGeom prst="rect">
-            <a:avLst/>
-          </a:prstGeom>
-          <a:noFill/>
-          <a:ln/>
-        </p:spPr>
-        <p:txBody>
-          <a:bodyPr wrap="square" rtlCol="0" anchor="ctr"/>
-          <a:lstStyle/>
-          <a:p>
-            <a:pPr indent="0" marL="0">
-              <a:buNone/>
-            </a:pPr>
-            <a:r>
-              <a:rPr lang="en-US" sz="1400" b="1" dirty="0">
-                <a:solidFill>
-                  <a:srgbClr val="F5B800"/>
-                </a:solidFill>
-                <a:latin typeface="Georgia" pitchFamily="34" charset="0"/>
-                <a:ea typeface="Georgia" pitchFamily="34" charset="-122"/>
-                <a:cs typeface="Georgia" pitchFamily="34" charset="-120"/>
-              </a:rPr>
-              <a:t>Ресурсы MVP</a:t>
-            </a:r>
-            <a:endParaRPr lang="en-US" sz="1400" dirty="0"/>
-          </a:p>
-        </p:txBody>
-      </p:sp>
-      <p:sp>
-        <p:nvSpPr>
-          <p:cNvPr id="27" name="Text 21"/>
-          <p:cNvSpPr/>
-          <p:nvPr/>
-        </p:nvSpPr>
-        <p:spPr>
-          <a:xfrm>
-            <a:off x="6355080" y="5166360"/>
-            <a:ext cx="2331720" cy="1188720"/>
-          </a:xfrm>
-          <a:prstGeom prst="rect">
-            <a:avLst/>
-          </a:prstGeom>
-          <a:noFill/>
-          <a:ln/>
-        </p:spPr>
-        <p:txBody>
-          <a:bodyPr wrap="square" rtlCol="0" anchor="t"/>
-          <a:lstStyle/>
-          <a:p>
-            <a:pPr marL="342900" indent="-342900">
-              <a:spcAft>
-                <a:spcPts val="400"/>
-              </a:spcAft>
-              <a:buSzPct val="100000"/>
-              <a:buChar char="•"/>
-            </a:pPr>
-            <a:r>
-              <a:rPr lang="en-US" sz="1200" dirty="0">
-                <a:solidFill>
-                  <a:srgbClr val="FFFFFF"/>
-                </a:solidFill>
-                <a:latin typeface="Calibri" pitchFamily="34" charset="0"/>
-                <a:ea typeface="Calibri" pitchFamily="34" charset="-122"/>
-                <a:cs typeface="Calibri" pitchFamily="34" charset="-120"/>
-              </a:rPr>
-              <a:t>1 VPS · 2 vCPU / 4 ГБ</a:t>
-            </a:r>
-            <a:endParaRPr lang="en-US" sz="1200" dirty="0"/>
-          </a:p>
-          <a:p>
-            <a:pPr marL="342900" indent="-342900">
-              <a:spcAft>
-                <a:spcPts val="400"/>
-              </a:spcAft>
-              <a:buSzPct val="100000"/>
-              <a:buChar char="•"/>
-            </a:pPr>
-            <a:r>
-              <a:rPr lang="en-US" sz="1200" dirty="0">
-                <a:solidFill>
-                  <a:srgbClr val="FFFFFF"/>
-                </a:solidFill>
-                <a:latin typeface="Calibri" pitchFamily="34" charset="0"/>
-                <a:ea typeface="Calibri" pitchFamily="34" charset="-122"/>
-                <a:cs typeface="Calibri" pitchFamily="34" charset="-120"/>
-              </a:rPr>
-              <a:t>GigaChat API (PERS)</a:t>
-            </a:r>
-            <a:endParaRPr lang="en-US" sz="1200" dirty="0"/>
-          </a:p>
-          <a:p>
-            <a:pPr marL="342900" indent="-342900">
-              <a:spcAft>
-                <a:spcPts val="400"/>
-              </a:spcAft>
-              <a:buSzPct val="100000"/>
-              <a:buChar char="•"/>
-            </a:pPr>
-            <a:r>
-              <a:rPr lang="en-US" sz="1200" dirty="0">
-                <a:solidFill>
-                  <a:srgbClr val="FFFFFF"/>
-                </a:solidFill>
-                <a:latin typeface="Calibri" pitchFamily="34" charset="0"/>
-                <a:ea typeface="Calibri" pitchFamily="34" charset="-122"/>
-                <a:cs typeface="Calibri" pitchFamily="34" charset="-120"/>
-              </a:rPr>
-              <a:t>Docker Compose</a:t>
-            </a:r>
-            <a:endParaRPr lang="en-US" sz="1200" dirty="0"/>
-          </a:p>
-          <a:p>
-            <a:pPr marL="342900" indent="-342900">
-              <a:spcAft>
-                <a:spcPts val="400"/>
-              </a:spcAft>
-              <a:buSzPct val="100000"/>
-              <a:buChar char="•"/>
-            </a:pPr>
-            <a:r>
-              <a:rPr lang="en-US" sz="1200" dirty="0">
-                <a:solidFill>
-                  <a:srgbClr val="66D9A7"/>
-                </a:solidFill>
-                <a:latin typeface="Calibri" pitchFamily="34" charset="0"/>
-                <a:ea typeface="Calibri" pitchFamily="34" charset="-122"/>
-                <a:cs typeface="Calibri" pitchFamily="34" charset="-120"/>
-              </a:rPr>
-              <a:t>Дёшево в эксплуатации</a:t>
-            </a:r>
-            <a:endParaRPr lang="en-US" sz="1200" dirty="0"/>
-          </a:p>
-        </p:txBody>
-      </p:sp>
-      <p:sp>
-        <p:nvSpPr>
-          <p:cNvPr id="28" name="Shape 22"/>
-          <p:cNvSpPr/>
-          <p:nvPr/>
-        </p:nvSpPr>
-        <p:spPr>
-          <a:xfrm>
-            <a:off x="8915400" y="4617720"/>
-            <a:ext cx="2606040" cy="1783080"/>
+              <a:t>2. Стрим: фазы и каркас этапов в реальном времени</a:t>
+            </a:r>
+            <a:endParaRPr lang="en-US" sz="1300" dirty="0"/>
+          </a:p>
+        </p:txBody>
+      </p:sp>
+      <p:sp>
+        <p:nvSpPr>
+          <p:cNvPr id="13" name="Shape 9"/>
+          <p:cNvSpPr/>
+          <p:nvPr/>
+        </p:nvSpPr>
+        <p:spPr>
+          <a:xfrm>
+            <a:off x="502920" y="5760720"/>
+            <a:ext cx="11155680" cy="868680"/>
           </a:xfrm>
           <a:prstGeom prst="rect">
             <a:avLst/>
@@ -16977,7 +17543,7 @@
           <a:solidFill>
             <a:srgbClr val="F8F9F7"/>
           </a:solidFill>
-          <a:ln w="16510">
+          <a:ln w="15240">
             <a:solidFill>
               <a:srgbClr val="21A663"/>
             </a:solidFill>
@@ -16987,14 +17553,14 @@
       </p:sp>
       <p:sp>
         <p:nvSpPr>
-          <p:cNvPr id="29" name="Text 23"/>
-          <p:cNvSpPr/>
-          <p:nvPr/>
-        </p:nvSpPr>
-        <p:spPr>
-          <a:xfrm>
-            <a:off x="9098280" y="4754880"/>
-            <a:ext cx="2286000" cy="365760"/>
+          <p:cNvPr id="14" name="Text 10"/>
+          <p:cNvSpPr/>
+          <p:nvPr/>
+        </p:nvSpPr>
+        <p:spPr>
+          <a:xfrm>
+            <a:off x="685800" y="5852160"/>
+            <a:ext cx="3200400" cy="365760"/>
           </a:xfrm>
           <a:prstGeom prst="rect">
             <a:avLst/>
@@ -17010,7 +17576,7 @@
               <a:buNone/>
             </a:pPr>
             <a:r>
-              <a:rPr lang="en-US" sz="1400" b="1" dirty="0">
+              <a:rPr lang="en-US" sz="1300" b="1" dirty="0">
                 <a:solidFill>
                   <a:srgbClr val="21A663"/>
                 </a:solidFill>
@@ -17018,22 +17584,22 @@
                 <a:ea typeface="Georgia" pitchFamily="34" charset="-122"/>
                 <a:cs typeface="Georgia" pitchFamily="34" charset="-120"/>
               </a:rPr>
-              <a:t>Развитие</a:t>
-            </a:r>
-            <a:endParaRPr lang="en-US" sz="1400" dirty="0"/>
-          </a:p>
-        </p:txBody>
-      </p:sp>
-      <p:sp>
-        <p:nvSpPr>
-          <p:cNvPr id="30" name="Text 24"/>
-          <p:cNvSpPr/>
-          <p:nvPr/>
-        </p:nvSpPr>
-        <p:spPr>
-          <a:xfrm>
-            <a:off x="9144000" y="5166360"/>
-            <a:ext cx="2331720" cy="1188720"/>
+              <a:t>Что уже работает</a:t>
+            </a:r>
+            <a:endParaRPr lang="en-US" sz="1300" dirty="0"/>
+          </a:p>
+        </p:txBody>
+      </p:sp>
+      <p:sp>
+        <p:nvSpPr>
+          <p:cNvPr id="15" name="Text 11"/>
+          <p:cNvSpPr/>
+          <p:nvPr/>
+        </p:nvSpPr>
+        <p:spPr>
+          <a:xfrm>
+            <a:off x="777240" y="6217920"/>
+            <a:ext cx="10698480" cy="411480"/>
           </a:xfrm>
           <a:prstGeom prst="rect">
             <a:avLst/>
@@ -17046,14 +17612,11 @@
           <a:lstStyle/>
           <a:p>
             <a:pPr marL="342900" indent="-342900">
-              <a:spcAft>
-                <a:spcPts val="300"/>
-              </a:spcAft>
               <a:buSzPct val="100000"/>
-              <a:buChar char="•"/>
-            </a:pPr>
-            <a:r>
-              <a:rPr lang="en-US" sz="1150" dirty="0">
+              <a:buChar char="✓"/>
+            </a:pPr>
+            <a:r>
+              <a:rPr lang="en-US" sz="1050" dirty="0">
                 <a:solidFill>
                   <a:srgbClr val="14160F"/>
                 </a:solidFill>
@@ -17061,20 +17624,17 @@
                 <a:ea typeface="Calibri" pitchFamily="34" charset="-122"/>
                 <a:cs typeface="Calibri" pitchFamily="34" charset="-120"/>
               </a:rPr>
-              <a:t>Интеграция с эл. журналами</a:t>
-            </a:r>
-            <a:endParaRPr lang="en-US" sz="1150" dirty="0"/>
+              <a:t>Генерация по блокам РоВ-уровня в 8 форматах · опора на методички (RAG) · pre-match по библиотеке</a:t>
+            </a:r>
+            <a:endParaRPr lang="en-US" sz="1050" dirty="0"/>
           </a:p>
           <a:p>
             <a:pPr marL="342900" indent="-342900">
-              <a:spcAft>
-                <a:spcPts val="300"/>
-              </a:spcAft>
               <a:buSzPct val="100000"/>
-              <a:buChar char="•"/>
-            </a:pPr>
-            <a:r>
-              <a:rPr lang="en-US" sz="1150" dirty="0">
+              <a:buChar char="✓"/>
+            </a:pPr>
+            <a:r>
+              <a:rPr lang="en-US" sz="1050" dirty="0">
                 <a:solidFill>
                   <a:srgbClr val="14160F"/>
                 </a:solidFill>
@@ -17082,51 +17642,9 @@
                 <a:ea typeface="Calibri" pitchFamily="34" charset="-122"/>
                 <a:cs typeface="Calibri" pitchFamily="34" charset="-120"/>
               </a:rPr>
-              <a:t>Модерация контента методистами</a:t>
-            </a:r>
-            <a:endParaRPr lang="en-US" sz="1150" dirty="0"/>
-          </a:p>
-          <a:p>
-            <a:pPr marL="342900" indent="-342900">
-              <a:spcAft>
-                <a:spcPts val="300"/>
-              </a:spcAft>
-              <a:buSzPct val="100000"/>
-              <a:buChar char="•"/>
-            </a:pPr>
-            <a:r>
-              <a:rPr lang="en-US" sz="1150" dirty="0">
-                <a:solidFill>
-                  <a:srgbClr val="14160F"/>
-                </a:solidFill>
-                <a:latin typeface="Calibri" pitchFamily="34" charset="0"/>
-                <a:ea typeface="Calibri" pitchFamily="34" charset="-122"/>
-                <a:cs typeface="Calibri" pitchFamily="34" charset="-120"/>
-              </a:rPr>
-              <a:t>Мульти-школьные тенанты</a:t>
-            </a:r>
-            <a:endParaRPr lang="en-US" sz="1150" dirty="0"/>
-          </a:p>
-          <a:p>
-            <a:pPr marL="342900" indent="-342900">
-              <a:spcAft>
-                <a:spcPts val="300"/>
-              </a:spcAft>
-              <a:buSzPct val="100000"/>
-              <a:buChar char="•"/>
-            </a:pPr>
-            <a:r>
-              <a:rPr lang="en-US" sz="1150" dirty="0">
-                <a:solidFill>
-                  <a:srgbClr val="14160F"/>
-                </a:solidFill>
-                <a:latin typeface="Calibri" pitchFamily="34" charset="0"/>
-                <a:ea typeface="Calibri" pitchFamily="34" charset="-122"/>
-                <a:cs typeface="Calibri" pitchFamily="34" charset="-120"/>
-              </a:rPr>
-              <a:t>Аналитика вовлечённости</a:t>
-            </a:r>
-            <a:endParaRPr lang="en-US" sz="1150" dirty="0"/>
+              <a:t>Загрузка плана и своего материала (PDF/DOCX/PPTX/TXT) · локальная анонимизация ПДн</a:t>
+            </a:r>
+            <a:endParaRPr lang="en-US" sz="1050" dirty="0"/>
           </a:p>
         </p:txBody>
       </p:sp>
@@ -17215,7 +17733,7 @@
                 <a:ea typeface="Calibri" pitchFamily="34" charset="-122"/>
                 <a:cs typeface="Calibri" pitchFamily="34" charset="-120"/>
               </a:rPr>
-              <a:t>07 — ДОРОЖНАЯ КАРТА</a:t>
+              <a:t>06 — MVP · ДЕМО-ПУТЬ 2/2</a:t>
             </a:r>
             <a:endParaRPr lang="en-US" sz="1300" dirty="0"/>
           </a:p>
@@ -17254,7 +17772,7 @@
                 <a:ea typeface="Georgia" pitchFamily="34" charset="-122"/>
                 <a:cs typeface="Georgia" pitchFamily="34" charset="-120"/>
               </a:rPr>
-              <a:t>От MVP к масштабу</a:t>
+              <a:t>Редактор → экспорт</a:t>
             </a:r>
             <a:endParaRPr lang="en-US" sz="3200" dirty="0"/>
           </a:p>
@@ -17268,90 +17786,8 @@
         </p:nvSpPr>
         <p:spPr>
           <a:xfrm>
-            <a:off x="914400" y="2468880"/>
-            <a:ext cx="10332720" cy="0"/>
-          </a:xfrm>
-          <a:prstGeom prst="line">
-            <a:avLst/>
-          </a:prstGeom>
-          <a:noFill/>
-          <a:ln w="25400">
-            <a:solidFill>
-              <a:srgbClr val="E4E6E1"/>
-            </a:solidFill>
-            <a:prstDash val="solid"/>
-          </a:ln>
-        </p:spPr>
-      </p:sp>
-      <p:sp>
-        <p:nvSpPr>
-          <p:cNvPr id="6" name="Shape 4"/>
-          <p:cNvSpPr/>
-          <p:nvPr/>
-        </p:nvSpPr>
-        <p:spPr>
-          <a:xfrm>
-            <a:off x="960120" y="2286000"/>
-            <a:ext cx="365760" cy="365760"/>
-          </a:xfrm>
-          <a:prstGeom prst="ellipse">
-            <a:avLst/>
-          </a:prstGeom>
-          <a:solidFill>
-            <a:srgbClr val="21A663"/>
-          </a:solidFill>
-          <a:ln/>
-        </p:spPr>
-      </p:sp>
-      <p:sp>
-        <p:nvSpPr>
-          <p:cNvPr id="7" name="Text 5"/>
-          <p:cNvSpPr/>
-          <p:nvPr/>
-        </p:nvSpPr>
-        <p:spPr>
-          <a:xfrm>
-            <a:off x="960120" y="2286000"/>
-            <a:ext cx="365760" cy="365760"/>
-          </a:xfrm>
-          <a:prstGeom prst="rect">
-            <a:avLst/>
-          </a:prstGeom>
-          <a:noFill/>
-          <a:ln/>
-        </p:spPr>
-        <p:txBody>
-          <a:bodyPr wrap="square" rtlCol="0" anchor="ctr"/>
-          <a:lstStyle/>
-          <a:p>
-            <a:pPr algn="ctr" indent="0" marL="0">
-              <a:buNone/>
-            </a:pPr>
-            <a:r>
-              <a:rPr lang="en-US" sz="1300" b="1" dirty="0">
-                <a:solidFill>
-                  <a:srgbClr val="FFFFFF"/>
-                </a:solidFill>
-                <a:latin typeface="Georgia" pitchFamily="34" charset="0"/>
-                <a:ea typeface="Georgia" pitchFamily="34" charset="-122"/>
-                <a:cs typeface="Georgia" pitchFamily="34" charset="-120"/>
-              </a:rPr>
-              <a:t>1</a:t>
-            </a:r>
-            <a:endParaRPr lang="en-US" sz="1300" dirty="0"/>
-          </a:p>
-        </p:txBody>
-      </p:sp>
-      <p:sp>
-        <p:nvSpPr>
-          <p:cNvPr id="8" name="Shape 6"/>
-          <p:cNvSpPr/>
-          <p:nvPr/>
-        </p:nvSpPr>
-        <p:spPr>
-          <a:xfrm>
-            <a:off x="640080" y="2926080"/>
-            <a:ext cx="2606040" cy="2651760"/>
+            <a:off x="502920" y="1874520"/>
+            <a:ext cx="5532120" cy="3703320"/>
           </a:xfrm>
           <a:prstGeom prst="rect">
             <a:avLst/>
@@ -17374,36 +17810,59 @@
           </a:effectLst>
         </p:spPr>
       </p:sp>
-      <p:sp>
-        <p:nvSpPr>
-          <p:cNvPr id="9" name="Shape 7"/>
-          <p:cNvSpPr/>
-          <p:nvPr/>
-        </p:nvSpPr>
-        <p:spPr>
-          <a:xfrm>
-            <a:off x="640080" y="2926080"/>
-            <a:ext cx="2606040" cy="109728"/>
+      <p:pic>
+        <p:nvPicPr>
+          <p:cNvPr id="6" name="Image 0" descr="/home/nikit/planwise/artifacts/5-editor-regen.png">    </p:cNvPr>
+          <p:cNvPicPr>
+            <a:picLocks noChangeAspect="1"/>
+          </p:cNvPicPr>
+          <p:nvPr/>
+        </p:nvPicPr>
+        <p:blipFill>
+          <a:blip r:embed="rId1"/>
+          <a:srcRect l="0" r="0" t="0" b="0"/>
+          <a:stretch/>
+        </p:blipFill>
+        <p:spPr>
+          <a:xfrm>
+            <a:off x="594360" y="1965960"/>
+            <a:ext cx="5349240" cy="3108960"/>
+          </a:xfrm>
+          <a:prstGeom prst="rect">
+            <a:avLst/>
+          </a:prstGeom>
+        </p:spPr>
+      </p:pic>
+      <p:sp>
+        <p:nvSpPr>
+          <p:cNvPr id="7" name="Shape 4"/>
+          <p:cNvSpPr/>
+          <p:nvPr/>
+        </p:nvSpPr>
+        <p:spPr>
+          <a:xfrm>
+            <a:off x="502920" y="5166360"/>
+            <a:ext cx="5532120" cy="411480"/>
           </a:xfrm>
           <a:prstGeom prst="rect">
             <a:avLst/>
           </a:prstGeom>
           <a:solidFill>
-            <a:srgbClr val="21A663"/>
+            <a:srgbClr val="0E4F30"/>
           </a:solidFill>
           <a:ln/>
         </p:spPr>
       </p:sp>
       <p:sp>
         <p:nvSpPr>
-          <p:cNvPr id="10" name="Text 8"/>
-          <p:cNvSpPr/>
-          <p:nvPr/>
-        </p:nvSpPr>
-        <p:spPr>
-          <a:xfrm>
-            <a:off x="841248" y="3127248"/>
-            <a:ext cx="2240280" cy="457200"/>
+          <p:cNvPr id="8" name="Text 5"/>
+          <p:cNvSpPr/>
+          <p:nvPr/>
+        </p:nvSpPr>
+        <p:spPr>
+          <a:xfrm>
+            <a:off x="667512" y="5166360"/>
+            <a:ext cx="5202936" cy="411480"/>
           </a:xfrm>
           <a:prstGeom prst="rect">
             <a:avLst/>
@@ -17419,174 +17878,15 @@
               <a:buNone/>
             </a:pPr>
             <a:r>
-              <a:rPr lang="en-US" sz="1600" b="1" dirty="0">
-                <a:solidFill>
-                  <a:srgbClr val="14160F"/>
-                </a:solidFill>
-                <a:latin typeface="Georgia" pitchFamily="34" charset="0"/>
-                <a:ea typeface="Georgia" pitchFamily="34" charset="-122"/>
-                <a:cs typeface="Georgia" pitchFamily="34" charset="-120"/>
-              </a:rPr>
-              <a:t>Развёрнуто на проде</a:t>
-            </a:r>
-            <a:endParaRPr lang="en-US" sz="1600" dirty="0"/>
-          </a:p>
-        </p:txBody>
-      </p:sp>
-      <p:sp>
-        <p:nvSpPr>
-          <p:cNvPr id="11" name="Text 9"/>
-          <p:cNvSpPr/>
-          <p:nvPr/>
-        </p:nvSpPr>
-        <p:spPr>
-          <a:xfrm>
-            <a:off x="868680" y="3657600"/>
-            <a:ext cx="2194560" cy="1828800"/>
-          </a:xfrm>
-          <a:prstGeom prst="rect">
-            <a:avLst/>
-          </a:prstGeom>
-          <a:noFill/>
-          <a:ln/>
-        </p:spPr>
-        <p:txBody>
-          <a:bodyPr wrap="square" rtlCol="0" anchor="t"/>
-          <a:lstStyle/>
-          <a:p>
-            <a:pPr marL="342900" indent="-342900">
-              <a:spcAft>
-                <a:spcPts val="800"/>
-              </a:spcAft>
-              <a:buSzPct val="100000"/>
-              <a:buChar char="•"/>
-            </a:pPr>
-            <a:r>
-              <a:rPr lang="en-US" sz="1200" dirty="0">
-                <a:solidFill>
-                  <a:srgbClr val="717670"/>
+              <a:rPr lang="en-US" sz="1300" b="1" dirty="0">
+                <a:solidFill>
+                  <a:srgbClr val="FFFFFF"/>
                 </a:solidFill>
                 <a:latin typeface="Calibri" pitchFamily="34" charset="0"/>
                 <a:ea typeface="Calibri" pitchFamily="34" charset="-122"/>
                 <a:cs typeface="Calibri" pitchFamily="34" charset="-120"/>
               </a:rPr>
-              <a:t>MVP + RAG-корпус методичек РоВ · домен plan-wise.ru + HTTPS</a:t>
-            </a:r>
-            <a:endParaRPr lang="en-US" sz="1200" dirty="0"/>
-          </a:p>
-          <a:p>
-            <a:pPr marL="342900" indent="-342900">
-              <a:spcAft>
-                <a:spcPts val="800"/>
-              </a:spcAft>
-              <a:buSzPct val="100000"/>
-              <a:buChar char="•"/>
-            </a:pPr>
-            <a:r>
-              <a:rPr lang="en-US" sz="1200" dirty="0">
-                <a:solidFill>
-                  <a:srgbClr val="717670"/>
-                </a:solidFill>
-                <a:latin typeface="Calibri" pitchFamily="34" charset="0"/>
-                <a:ea typeface="Calibri" pitchFamily="34" charset="-122"/>
-                <a:cs typeface="Calibri" pitchFamily="34" charset="-120"/>
-              </a:rPr>
-              <a:t>Docker Compose · библиотека наполнена · порог откалиброван</a:t>
-            </a:r>
-            <a:endParaRPr lang="en-US" sz="1200" dirty="0"/>
-          </a:p>
-        </p:txBody>
-      </p:sp>
-      <p:sp>
-        <p:nvSpPr>
-          <p:cNvPr id="12" name="Text 10"/>
-          <p:cNvSpPr/>
-          <p:nvPr/>
-        </p:nvSpPr>
-        <p:spPr>
-          <a:xfrm>
-            <a:off x="3246120" y="3931920"/>
-            <a:ext cx="182880" cy="365760"/>
-          </a:xfrm>
-          <a:prstGeom prst="rect">
-            <a:avLst/>
-          </a:prstGeom>
-          <a:noFill/>
-          <a:ln/>
-        </p:spPr>
-        <p:txBody>
-          <a:bodyPr wrap="square" rtlCol="0" anchor="ctr"/>
-          <a:lstStyle/>
-          <a:p>
-            <a:pPr algn="ctr" indent="0" marL="0">
-              <a:buNone/>
-            </a:pPr>
-            <a:r>
-              <a:rPr lang="en-US" sz="1800" b="1" dirty="0">
-                <a:solidFill>
-                  <a:srgbClr val="21A663"/>
-                </a:solidFill>
-              </a:rPr>
-              <a:t>→</a:t>
-            </a:r>
-            <a:endParaRPr lang="en-US" sz="1800" dirty="0"/>
-          </a:p>
-        </p:txBody>
-      </p:sp>
-      <p:sp>
-        <p:nvSpPr>
-          <p:cNvPr id="13" name="Shape 11"/>
-          <p:cNvSpPr/>
-          <p:nvPr/>
-        </p:nvSpPr>
-        <p:spPr>
-          <a:xfrm>
-            <a:off x="3749040" y="2286000"/>
-            <a:ext cx="365760" cy="365760"/>
-          </a:xfrm>
-          <a:prstGeom prst="ellipse">
-            <a:avLst/>
-          </a:prstGeom>
-          <a:solidFill>
-            <a:srgbClr val="F5B800"/>
-          </a:solidFill>
-          <a:ln/>
-        </p:spPr>
-      </p:sp>
-      <p:sp>
-        <p:nvSpPr>
-          <p:cNvPr id="14" name="Text 12"/>
-          <p:cNvSpPr/>
-          <p:nvPr/>
-        </p:nvSpPr>
-        <p:spPr>
-          <a:xfrm>
-            <a:off x="3749040" y="2286000"/>
-            <a:ext cx="365760" cy="365760"/>
-          </a:xfrm>
-          <a:prstGeom prst="rect">
-            <a:avLst/>
-          </a:prstGeom>
-          <a:noFill/>
-          <a:ln/>
-        </p:spPr>
-        <p:txBody>
-          <a:bodyPr wrap="square" rtlCol="0" anchor="ctr"/>
-          <a:lstStyle/>
-          <a:p>
-            <a:pPr algn="ctr" indent="0" marL="0">
-              <a:buNone/>
-            </a:pPr>
-            <a:r>
-              <a:rPr lang="en-US" sz="1300" b="1" dirty="0">
-                <a:solidFill>
-                  <a:srgbClr val="FFFFFF"/>
-                </a:solidFill>
-                <a:latin typeface="Georgia" pitchFamily="34" charset="0"/>
-                <a:ea typeface="Georgia" pitchFamily="34" charset="-122"/>
-                <a:cs typeface="Georgia" pitchFamily="34" charset="-120"/>
-              </a:rPr>
-              <a:t>2</a:t>
+              <a:t>3. Редактор: ↑↓ reorder · 🎲 регенерация · add/del · история</a:t>
             </a:r>
             <a:endParaRPr lang="en-US" sz="1300" dirty="0"/>
           </a:p>
@@ -17594,14 +17894,14 @@
       </p:sp>
       <p:sp>
         <p:nvSpPr>
-          <p:cNvPr id="15" name="Shape 13"/>
-          <p:cNvSpPr/>
-          <p:nvPr/>
-        </p:nvSpPr>
-        <p:spPr>
-          <a:xfrm>
-            <a:off x="3429000" y="2926080"/>
-            <a:ext cx="2606040" cy="2651760"/>
+          <p:cNvPr id="9" name="Shape 6"/>
+          <p:cNvSpPr/>
+          <p:nvPr/>
+        </p:nvSpPr>
+        <p:spPr>
+          <a:xfrm>
+            <a:off x="6172200" y="1874520"/>
+            <a:ext cx="5532120" cy="3703320"/>
           </a:xfrm>
           <a:prstGeom prst="rect">
             <a:avLst/>
@@ -17624,36 +17924,59 @@
           </a:effectLst>
         </p:spPr>
       </p:sp>
-      <p:sp>
-        <p:nvSpPr>
-          <p:cNvPr id="16" name="Shape 14"/>
-          <p:cNvSpPr/>
-          <p:nvPr/>
-        </p:nvSpPr>
-        <p:spPr>
-          <a:xfrm>
-            <a:off x="3429000" y="2926080"/>
-            <a:ext cx="2606040" cy="109728"/>
+      <p:pic>
+        <p:nvPicPr>
+          <p:cNvPr id="10" name="Image 1" descr="/home/nikit/planwise/artifacts/4-export.png">    </p:cNvPr>
+          <p:cNvPicPr>
+            <a:picLocks noChangeAspect="1"/>
+          </p:cNvPicPr>
+          <p:nvPr/>
+        </p:nvPicPr>
+        <p:blipFill>
+          <a:blip r:embed="rId2"/>
+          <a:srcRect l="0" r="0" t="0" b="0"/>
+          <a:stretch/>
+        </p:blipFill>
+        <p:spPr>
+          <a:xfrm>
+            <a:off x="6263640" y="1965960"/>
+            <a:ext cx="5349240" cy="3108960"/>
+          </a:xfrm>
+          <a:prstGeom prst="rect">
+            <a:avLst/>
+          </a:prstGeom>
+        </p:spPr>
+      </p:pic>
+      <p:sp>
+        <p:nvSpPr>
+          <p:cNvPr id="11" name="Shape 7"/>
+          <p:cNvSpPr/>
+          <p:nvPr/>
+        </p:nvSpPr>
+        <p:spPr>
+          <a:xfrm>
+            <a:off x="6172200" y="5166360"/>
+            <a:ext cx="5532120" cy="411480"/>
           </a:xfrm>
           <a:prstGeom prst="rect">
             <a:avLst/>
           </a:prstGeom>
           <a:solidFill>
-            <a:srgbClr val="F5B800"/>
+            <a:srgbClr val="0E4F30"/>
           </a:solidFill>
           <a:ln/>
         </p:spPr>
       </p:sp>
       <p:sp>
         <p:nvSpPr>
-          <p:cNvPr id="17" name="Text 15"/>
-          <p:cNvSpPr/>
-          <p:nvPr/>
-        </p:nvSpPr>
-        <p:spPr>
-          <a:xfrm>
-            <a:off x="3630168" y="3127248"/>
-            <a:ext cx="2240280" cy="457200"/>
+          <p:cNvPr id="12" name="Text 8"/>
+          <p:cNvSpPr/>
+          <p:nvPr/>
+        </p:nvSpPr>
+        <p:spPr>
+          <a:xfrm>
+            <a:off x="6336792" y="5166360"/>
+            <a:ext cx="5202936" cy="411480"/>
           </a:xfrm>
           <a:prstGeom prst="rect">
             <a:avLst/>
@@ -17669,30 +17992,94 @@
               <a:buNone/>
             </a:pPr>
             <a:r>
-              <a:rPr lang="en-US" sz="1600" b="1" dirty="0">
-                <a:solidFill>
-                  <a:srgbClr val="14160F"/>
+              <a:rPr lang="en-US" sz="1300" b="1" dirty="0">
+                <a:solidFill>
+                  <a:srgbClr val="FFFFFF"/>
+                </a:solidFill>
+                <a:latin typeface="Calibri" pitchFamily="34" charset="0"/>
+                <a:ea typeface="Calibri" pitchFamily="34" charset="-122"/>
+                <a:cs typeface="Calibri" pitchFamily="34" charset="-120"/>
+              </a:rPr>
+              <a:t>4. Экспорт: PDF · DOCX · режим показа · персональная ссылка</a:t>
+            </a:r>
+            <a:endParaRPr lang="en-US" sz="1300" dirty="0"/>
+          </a:p>
+        </p:txBody>
+      </p:sp>
+      <p:sp>
+        <p:nvSpPr>
+          <p:cNvPr id="13" name="Shape 9"/>
+          <p:cNvSpPr/>
+          <p:nvPr/>
+        </p:nvSpPr>
+        <p:spPr>
+          <a:xfrm>
+            <a:off x="502920" y="5760720"/>
+            <a:ext cx="11155680" cy="868680"/>
+          </a:xfrm>
+          <a:prstGeom prst="rect">
+            <a:avLst/>
+          </a:prstGeom>
+          <a:solidFill>
+            <a:srgbClr val="F8F9F7"/>
+          </a:solidFill>
+          <a:ln w="15240">
+            <a:solidFill>
+              <a:srgbClr val="21A663"/>
+            </a:solidFill>
+            <a:prstDash val="solid"/>
+          </a:ln>
+        </p:spPr>
+      </p:sp>
+      <p:sp>
+        <p:nvSpPr>
+          <p:cNvPr id="14" name="Text 10"/>
+          <p:cNvSpPr/>
+          <p:nvPr/>
+        </p:nvSpPr>
+        <p:spPr>
+          <a:xfrm>
+            <a:off x="685800" y="5852160"/>
+            <a:ext cx="3200400" cy="365760"/>
+          </a:xfrm>
+          <a:prstGeom prst="rect">
+            <a:avLst/>
+          </a:prstGeom>
+          <a:noFill/>
+          <a:ln/>
+        </p:spPr>
+        <p:txBody>
+          <a:bodyPr wrap="square" rtlCol="0" anchor="ctr"/>
+          <a:lstStyle/>
+          <a:p>
+            <a:pPr indent="0" marL="0">
+              <a:buNone/>
+            </a:pPr>
+            <a:r>
+              <a:rPr lang="en-US" sz="1300" b="1" dirty="0">
+                <a:solidFill>
+                  <a:srgbClr val="21A663"/>
                 </a:solidFill>
                 <a:latin typeface="Georgia" pitchFamily="34" charset="0"/>
                 <a:ea typeface="Georgia" pitchFamily="34" charset="-122"/>
                 <a:cs typeface="Georgia" pitchFamily="34" charset="-120"/>
               </a:rPr>
-              <a:t>Перед демо</a:t>
-            </a:r>
-            <a:endParaRPr lang="en-US" sz="1600" dirty="0"/>
-          </a:p>
-        </p:txBody>
-      </p:sp>
-      <p:sp>
-        <p:nvSpPr>
-          <p:cNvPr id="18" name="Text 16"/>
-          <p:cNvSpPr/>
-          <p:nvPr/>
-        </p:nvSpPr>
-        <p:spPr>
-          <a:xfrm>
-            <a:off x="3657600" y="3657600"/>
-            <a:ext cx="2194560" cy="1828800"/>
+              <a:t>Что уже работает</a:t>
+            </a:r>
+            <a:endParaRPr lang="en-US" sz="1300" dirty="0"/>
+          </a:p>
+        </p:txBody>
+      </p:sp>
+      <p:sp>
+        <p:nvSpPr>
+          <p:cNvPr id="15" name="Text 11"/>
+          <p:cNvSpPr/>
+          <p:nvPr/>
+        </p:nvSpPr>
+        <p:spPr>
+          <a:xfrm>
+            <a:off x="777240" y="6217920"/>
+            <a:ext cx="10698480" cy="411480"/>
           </a:xfrm>
           <a:prstGeom prst="rect">
             <a:avLst/>
@@ -17705,584 +18092,39 @@
           <a:lstStyle/>
           <a:p>
             <a:pPr marL="342900" indent="-342900">
-              <a:spcAft>
-                <a:spcPts val="800"/>
-              </a:spcAft>
               <a:buSzPct val="100000"/>
-              <a:buChar char="•"/>
-            </a:pPr>
-            <a:r>
-              <a:rPr lang="en-US" sz="1200" dirty="0">
-                <a:solidFill>
-                  <a:srgbClr val="717670"/>
+              <a:buChar char="✓"/>
+            </a:pPr>
+            <a:r>
+              <a:rPr lang="en-US" sz="1050" dirty="0">
+                <a:solidFill>
+                  <a:srgbClr val="14160F"/>
                 </a:solidFill>
                 <a:latin typeface="Calibri" pitchFamily="34" charset="0"/>
                 <a:ea typeface="Calibri" pitchFamily="34" charset="-122"/>
                 <a:cs typeface="Calibri" pitchFamily="34" charset="-120"/>
               </a:rPr>
-              <a:t>Живой UAT golden-path</a:t>
-            </a:r>
-            <a:endParaRPr lang="en-US" sz="1200" dirty="0"/>
+              <a:t>Полноэкранный показ на проекторе · календарь-сетка · история версий с откатом</a:t>
+            </a:r>
+            <a:endParaRPr lang="en-US" sz="1050" dirty="0"/>
           </a:p>
           <a:p>
             <a:pPr marL="342900" indent="-342900">
-              <a:spcAft>
-                <a:spcPts val="800"/>
-              </a:spcAft>
               <a:buSzPct val="100000"/>
-              <a:buChar char="•"/>
-            </a:pPr>
-            <a:r>
-              <a:rPr lang="en-US" sz="1200" dirty="0">
-                <a:solidFill>
-                  <a:srgbClr val="717670"/>
+              <a:buChar char="✓"/>
+            </a:pPr>
+            <a:r>
+              <a:rPr lang="en-US" sz="1050" dirty="0">
+                <a:solidFill>
+                  <a:srgbClr val="14160F"/>
                 </a:solidFill>
                 <a:latin typeface="Calibri" pitchFamily="34" charset="0"/>
                 <a:ea typeface="Calibri" pitchFamily="34" charset="-122"/>
                 <a:cs typeface="Calibri" pitchFamily="34" charset="-120"/>
               </a:rPr>
-              <a:t>Скринкаст 5–7 мин + презентация</a:t>
-            </a:r>
-            <a:endParaRPr lang="en-US" sz="1200" dirty="0"/>
-          </a:p>
-        </p:txBody>
-      </p:sp>
-      <p:sp>
-        <p:nvSpPr>
-          <p:cNvPr id="19" name="Text 17"/>
-          <p:cNvSpPr/>
-          <p:nvPr/>
-        </p:nvSpPr>
-        <p:spPr>
-          <a:xfrm>
-            <a:off x="6035040" y="3931920"/>
-            <a:ext cx="182880" cy="365760"/>
-          </a:xfrm>
-          <a:prstGeom prst="rect">
-            <a:avLst/>
-          </a:prstGeom>
-          <a:noFill/>
-          <a:ln/>
-        </p:spPr>
-        <p:txBody>
-          <a:bodyPr wrap="square" rtlCol="0" anchor="ctr"/>
-          <a:lstStyle/>
-          <a:p>
-            <a:pPr algn="ctr" indent="0" marL="0">
-              <a:buNone/>
-            </a:pPr>
-            <a:r>
-              <a:rPr lang="en-US" sz="1800" b="1" dirty="0">
-                <a:solidFill>
-                  <a:srgbClr val="21A663"/>
-                </a:solidFill>
-              </a:rPr>
-              <a:t>→</a:t>
-            </a:r>
-            <a:endParaRPr lang="en-US" sz="1800" dirty="0"/>
-          </a:p>
-        </p:txBody>
-      </p:sp>
-      <p:sp>
-        <p:nvSpPr>
-          <p:cNvPr id="20" name="Shape 18"/>
-          <p:cNvSpPr/>
-          <p:nvPr/>
-        </p:nvSpPr>
-        <p:spPr>
-          <a:xfrm>
-            <a:off x="6537960" y="2286000"/>
-            <a:ext cx="365760" cy="365760"/>
-          </a:xfrm>
-          <a:prstGeom prst="ellipse">
-            <a:avLst/>
-          </a:prstGeom>
-          <a:solidFill>
-            <a:srgbClr val="2741E0"/>
-          </a:solidFill>
-          <a:ln/>
-        </p:spPr>
-      </p:sp>
-      <p:sp>
-        <p:nvSpPr>
-          <p:cNvPr id="21" name="Text 19"/>
-          <p:cNvSpPr/>
-          <p:nvPr/>
-        </p:nvSpPr>
-        <p:spPr>
-          <a:xfrm>
-            <a:off x="6537960" y="2286000"/>
-            <a:ext cx="365760" cy="365760"/>
-          </a:xfrm>
-          <a:prstGeom prst="rect">
-            <a:avLst/>
-          </a:prstGeom>
-          <a:noFill/>
-          <a:ln/>
-        </p:spPr>
-        <p:txBody>
-          <a:bodyPr wrap="square" rtlCol="0" anchor="ctr"/>
-          <a:lstStyle/>
-          <a:p>
-            <a:pPr algn="ctr" indent="0" marL="0">
-              <a:buNone/>
-            </a:pPr>
-            <a:r>
-              <a:rPr lang="en-US" sz="1300" b="1" dirty="0">
-                <a:solidFill>
-                  <a:srgbClr val="FFFFFF"/>
-                </a:solidFill>
-                <a:latin typeface="Georgia" pitchFamily="34" charset="0"/>
-                <a:ea typeface="Georgia" pitchFamily="34" charset="-122"/>
-                <a:cs typeface="Georgia" pitchFamily="34" charset="-120"/>
-              </a:rPr>
-              <a:t>3</a:t>
-            </a:r>
-            <a:endParaRPr lang="en-US" sz="1300" dirty="0"/>
-          </a:p>
-        </p:txBody>
-      </p:sp>
-      <p:sp>
-        <p:nvSpPr>
-          <p:cNvPr id="22" name="Shape 20"/>
-          <p:cNvSpPr/>
-          <p:nvPr/>
-        </p:nvSpPr>
-        <p:spPr>
-          <a:xfrm>
-            <a:off x="6217920" y="2926080"/>
-            <a:ext cx="2606040" cy="2651760"/>
-          </a:xfrm>
-          <a:prstGeom prst="rect">
-            <a:avLst/>
-          </a:prstGeom>
-          <a:solidFill>
-            <a:srgbClr val="FFFFFF"/>
-          </a:solidFill>
-          <a:ln w="12700">
-            <a:solidFill>
-              <a:srgbClr val="E4E6E1"/>
-            </a:solidFill>
-            <a:prstDash val="solid"/>
-          </a:ln>
-          <a:effectLst>
-            <a:outerShdw sx="100000" sy="100000" kx="0" ky="0" algn="bl" rotWithShape="0" blurRad="101600" dist="38100" dir="8100000">
-              <a:srgbClr val="000000">
-                <a:alpha val="12000"/>
-              </a:srgbClr>
-            </a:outerShdw>
-          </a:effectLst>
-        </p:spPr>
-      </p:sp>
-      <p:sp>
-        <p:nvSpPr>
-          <p:cNvPr id="23" name="Shape 21"/>
-          <p:cNvSpPr/>
-          <p:nvPr/>
-        </p:nvSpPr>
-        <p:spPr>
-          <a:xfrm>
-            <a:off x="6217920" y="2926080"/>
-            <a:ext cx="2606040" cy="109728"/>
-          </a:xfrm>
-          <a:prstGeom prst="rect">
-            <a:avLst/>
-          </a:prstGeom>
-          <a:solidFill>
-            <a:srgbClr val="2741E0"/>
-          </a:solidFill>
-          <a:ln/>
-        </p:spPr>
-      </p:sp>
-      <p:sp>
-        <p:nvSpPr>
-          <p:cNvPr id="24" name="Text 22"/>
-          <p:cNvSpPr/>
-          <p:nvPr/>
-        </p:nvSpPr>
-        <p:spPr>
-          <a:xfrm>
-            <a:off x="6419088" y="3127248"/>
-            <a:ext cx="2240280" cy="457200"/>
-          </a:xfrm>
-          <a:prstGeom prst="rect">
-            <a:avLst/>
-          </a:prstGeom>
-          <a:noFill/>
-          <a:ln/>
-        </p:spPr>
-        <p:txBody>
-          <a:bodyPr wrap="square" rtlCol="0" anchor="ctr"/>
-          <a:lstStyle/>
-          <a:p>
-            <a:pPr indent="0" marL="0">
-              <a:buNone/>
-            </a:pPr>
-            <a:r>
-              <a:rPr lang="en-US" sz="1600" b="1" dirty="0">
-                <a:solidFill>
-                  <a:srgbClr val="14160F"/>
-                </a:solidFill>
-                <a:latin typeface="Georgia" pitchFamily="34" charset="0"/>
-                <a:ea typeface="Georgia" pitchFamily="34" charset="-122"/>
-                <a:cs typeface="Georgia" pitchFamily="34" charset="-120"/>
-              </a:rPr>
-              <a:t>Пилот в школе</a:t>
-            </a:r>
-            <a:endParaRPr lang="en-US" sz="1600" dirty="0"/>
-          </a:p>
-        </p:txBody>
-      </p:sp>
-      <p:sp>
-        <p:nvSpPr>
-          <p:cNvPr id="25" name="Text 23"/>
-          <p:cNvSpPr/>
-          <p:nvPr/>
-        </p:nvSpPr>
-        <p:spPr>
-          <a:xfrm>
-            <a:off x="6446520" y="3657600"/>
-            <a:ext cx="2194560" cy="1828800"/>
-          </a:xfrm>
-          <a:prstGeom prst="rect">
-            <a:avLst/>
-          </a:prstGeom>
-          <a:noFill/>
-          <a:ln/>
-        </p:spPr>
-        <p:txBody>
-          <a:bodyPr wrap="square" rtlCol="0" anchor="t"/>
-          <a:lstStyle/>
-          <a:p>
-            <a:pPr marL="342900" indent="-342900">
-              <a:spcAft>
-                <a:spcPts val="800"/>
-              </a:spcAft>
-              <a:buSzPct val="100000"/>
-              <a:buChar char="•"/>
-            </a:pPr>
-            <a:r>
-              <a:rPr lang="en-US" sz="1200" dirty="0">
-                <a:solidFill>
-                  <a:srgbClr val="717670"/>
-                </a:solidFill>
-                <a:latin typeface="Calibri" pitchFamily="34" charset="0"/>
-                <a:ea typeface="Calibri" pitchFamily="34" charset="-122"/>
-                <a:cs typeface="Calibri" pitchFamily="34" charset="-120"/>
-              </a:rPr>
-              <a:t>Обкатка с реальными классными руководителями</a:t>
-            </a:r>
-            <a:endParaRPr lang="en-US" sz="1200" dirty="0"/>
-          </a:p>
-          <a:p>
-            <a:pPr marL="342900" indent="-342900">
-              <a:spcAft>
-                <a:spcPts val="800"/>
-              </a:spcAft>
-              <a:buSzPct val="100000"/>
-              <a:buChar char="•"/>
-            </a:pPr>
-            <a:r>
-              <a:rPr lang="en-US" sz="1200" dirty="0">
-                <a:solidFill>
-                  <a:srgbClr val="717670"/>
-                </a:solidFill>
-                <a:latin typeface="Calibri" pitchFamily="34" charset="0"/>
-                <a:ea typeface="Calibri" pitchFamily="34" charset="-122"/>
-                <a:cs typeface="Calibri" pitchFamily="34" charset="-120"/>
-              </a:rPr>
-              <a:t>Модерация контента методистами</a:t>
-            </a:r>
-            <a:endParaRPr lang="en-US" sz="1200" dirty="0"/>
-          </a:p>
-        </p:txBody>
-      </p:sp>
-      <p:sp>
-        <p:nvSpPr>
-          <p:cNvPr id="26" name="Text 24"/>
-          <p:cNvSpPr/>
-          <p:nvPr/>
-        </p:nvSpPr>
-        <p:spPr>
-          <a:xfrm>
-            <a:off x="8823960" y="3931920"/>
-            <a:ext cx="182880" cy="365760"/>
-          </a:xfrm>
-          <a:prstGeom prst="rect">
-            <a:avLst/>
-          </a:prstGeom>
-          <a:noFill/>
-          <a:ln/>
-        </p:spPr>
-        <p:txBody>
-          <a:bodyPr wrap="square" rtlCol="0" anchor="ctr"/>
-          <a:lstStyle/>
-          <a:p>
-            <a:pPr algn="ctr" indent="0" marL="0">
-              <a:buNone/>
-            </a:pPr>
-            <a:r>
-              <a:rPr lang="en-US" sz="1800" b="1" dirty="0">
-                <a:solidFill>
-                  <a:srgbClr val="21A663"/>
-                </a:solidFill>
-              </a:rPr>
-              <a:t>→</a:t>
-            </a:r>
-            <a:endParaRPr lang="en-US" sz="1800" dirty="0"/>
-          </a:p>
-        </p:txBody>
-      </p:sp>
-      <p:sp>
-        <p:nvSpPr>
-          <p:cNvPr id="27" name="Shape 25"/>
-          <p:cNvSpPr/>
-          <p:nvPr/>
-        </p:nvSpPr>
-        <p:spPr>
-          <a:xfrm>
-            <a:off x="9326880" y="2286000"/>
-            <a:ext cx="365760" cy="365760"/>
-          </a:xfrm>
-          <a:prstGeom prst="ellipse">
-            <a:avLst/>
-          </a:prstGeom>
-          <a:solidFill>
-            <a:srgbClr val="093520"/>
-          </a:solidFill>
-          <a:ln/>
-        </p:spPr>
-      </p:sp>
-      <p:sp>
-        <p:nvSpPr>
-          <p:cNvPr id="28" name="Text 26"/>
-          <p:cNvSpPr/>
-          <p:nvPr/>
-        </p:nvSpPr>
-        <p:spPr>
-          <a:xfrm>
-            <a:off x="9326880" y="2286000"/>
-            <a:ext cx="365760" cy="365760"/>
-          </a:xfrm>
-          <a:prstGeom prst="rect">
-            <a:avLst/>
-          </a:prstGeom>
-          <a:noFill/>
-          <a:ln/>
-        </p:spPr>
-        <p:txBody>
-          <a:bodyPr wrap="square" rtlCol="0" anchor="ctr"/>
-          <a:lstStyle/>
-          <a:p>
-            <a:pPr algn="ctr" indent="0" marL="0">
-              <a:buNone/>
-            </a:pPr>
-            <a:r>
-              <a:rPr lang="en-US" sz="1300" b="1" dirty="0">
-                <a:solidFill>
-                  <a:srgbClr val="FFFFFF"/>
-                </a:solidFill>
-                <a:latin typeface="Georgia" pitchFamily="34" charset="0"/>
-                <a:ea typeface="Georgia" pitchFamily="34" charset="-122"/>
-                <a:cs typeface="Georgia" pitchFamily="34" charset="-120"/>
-              </a:rPr>
-              <a:t>4</a:t>
-            </a:r>
-            <a:endParaRPr lang="en-US" sz="1300" dirty="0"/>
-          </a:p>
-        </p:txBody>
-      </p:sp>
-      <p:sp>
-        <p:nvSpPr>
-          <p:cNvPr id="29" name="Shape 27"/>
-          <p:cNvSpPr/>
-          <p:nvPr/>
-        </p:nvSpPr>
-        <p:spPr>
-          <a:xfrm>
-            <a:off x="9006840" y="2926080"/>
-            <a:ext cx="2606040" cy="2651760"/>
-          </a:xfrm>
-          <a:prstGeom prst="rect">
-            <a:avLst/>
-          </a:prstGeom>
-          <a:solidFill>
-            <a:srgbClr val="FFFFFF"/>
-          </a:solidFill>
-          <a:ln w="12700">
-            <a:solidFill>
-              <a:srgbClr val="E4E6E1"/>
-            </a:solidFill>
-            <a:prstDash val="solid"/>
-          </a:ln>
-          <a:effectLst>
-            <a:outerShdw sx="100000" sy="100000" kx="0" ky="0" algn="bl" rotWithShape="0" blurRad="101600" dist="38100" dir="8100000">
-              <a:srgbClr val="000000">
-                <a:alpha val="12000"/>
-              </a:srgbClr>
-            </a:outerShdw>
-          </a:effectLst>
-        </p:spPr>
-      </p:sp>
-      <p:sp>
-        <p:nvSpPr>
-          <p:cNvPr id="30" name="Shape 28"/>
-          <p:cNvSpPr/>
-          <p:nvPr/>
-        </p:nvSpPr>
-        <p:spPr>
-          <a:xfrm>
-            <a:off x="9006840" y="2926080"/>
-            <a:ext cx="2606040" cy="109728"/>
-          </a:xfrm>
-          <a:prstGeom prst="rect">
-            <a:avLst/>
-          </a:prstGeom>
-          <a:solidFill>
-            <a:srgbClr val="093520"/>
-          </a:solidFill>
-          <a:ln/>
-        </p:spPr>
-      </p:sp>
-      <p:sp>
-        <p:nvSpPr>
-          <p:cNvPr id="31" name="Text 29"/>
-          <p:cNvSpPr/>
-          <p:nvPr/>
-        </p:nvSpPr>
-        <p:spPr>
-          <a:xfrm>
-            <a:off x="9208008" y="3127248"/>
-            <a:ext cx="2240280" cy="457200"/>
-          </a:xfrm>
-          <a:prstGeom prst="rect">
-            <a:avLst/>
-          </a:prstGeom>
-          <a:noFill/>
-          <a:ln/>
-        </p:spPr>
-        <p:txBody>
-          <a:bodyPr wrap="square" rtlCol="0" anchor="ctr"/>
-          <a:lstStyle/>
-          <a:p>
-            <a:pPr indent="0" marL="0">
-              <a:buNone/>
-            </a:pPr>
-            <a:r>
-              <a:rPr lang="en-US" sz="1600" b="1" dirty="0">
-                <a:solidFill>
-                  <a:srgbClr val="14160F"/>
-                </a:solidFill>
-                <a:latin typeface="Georgia" pitchFamily="34" charset="0"/>
-                <a:ea typeface="Georgia" pitchFamily="34" charset="-122"/>
-                <a:cs typeface="Georgia" pitchFamily="34" charset="-120"/>
-              </a:rPr>
-              <a:t>Масштаб B2B</a:t>
-            </a:r>
-            <a:endParaRPr lang="en-US" sz="1600" dirty="0"/>
-          </a:p>
-        </p:txBody>
-      </p:sp>
-      <p:sp>
-        <p:nvSpPr>
-          <p:cNvPr id="32" name="Text 30"/>
-          <p:cNvSpPr/>
-          <p:nvPr/>
-        </p:nvSpPr>
-        <p:spPr>
-          <a:xfrm>
-            <a:off x="9235440" y="3657600"/>
-            <a:ext cx="2194560" cy="1828800"/>
-          </a:xfrm>
-          <a:prstGeom prst="rect">
-            <a:avLst/>
-          </a:prstGeom>
-          <a:noFill/>
-          <a:ln/>
-        </p:spPr>
-        <p:txBody>
-          <a:bodyPr wrap="square" rtlCol="0" anchor="t"/>
-          <a:lstStyle/>
-          <a:p>
-            <a:pPr marL="342900" indent="-342900">
-              <a:spcAft>
-                <a:spcPts val="800"/>
-              </a:spcAft>
-              <a:buSzPct val="100000"/>
-              <a:buChar char="•"/>
-            </a:pPr>
-            <a:r>
-              <a:rPr lang="en-US" sz="1200" dirty="0">
-                <a:solidFill>
-                  <a:srgbClr val="717670"/>
-                </a:solidFill>
-                <a:latin typeface="Calibri" pitchFamily="34" charset="0"/>
-                <a:ea typeface="Calibri" pitchFamily="34" charset="-122"/>
-                <a:cs typeface="Calibri" pitchFamily="34" charset="-120"/>
-              </a:rPr>
-              <a:t>Подписка для школ и управлений образования</a:t>
-            </a:r>
-            <a:endParaRPr lang="en-US" sz="1200" dirty="0"/>
-          </a:p>
-          <a:p>
-            <a:pPr marL="342900" indent="-342900">
-              <a:spcAft>
-                <a:spcPts val="800"/>
-              </a:spcAft>
-              <a:buSzPct val="100000"/>
-              <a:buChar char="•"/>
-            </a:pPr>
-            <a:r>
-              <a:rPr lang="en-US" sz="1200" dirty="0">
-                <a:solidFill>
-                  <a:srgbClr val="717670"/>
-                </a:solidFill>
-                <a:latin typeface="Calibri" pitchFamily="34" charset="0"/>
-                <a:ea typeface="Calibri" pitchFamily="34" charset="-122"/>
-                <a:cs typeface="Calibri" pitchFamily="34" charset="-120"/>
-              </a:rPr>
-              <a:t>Интеграции с журналами · аналитика воспитания</a:t>
-            </a:r>
-            <a:endParaRPr lang="en-US" sz="1200" dirty="0"/>
-          </a:p>
-        </p:txBody>
-      </p:sp>
-      <p:sp>
-        <p:nvSpPr>
-          <p:cNvPr id="33" name="Text 31"/>
-          <p:cNvSpPr/>
-          <p:nvPr/>
-        </p:nvSpPr>
-        <p:spPr>
-          <a:xfrm>
-            <a:off x="640080" y="5852160"/>
-            <a:ext cx="10881360" cy="457200"/>
-          </a:xfrm>
-          <a:prstGeom prst="rect">
-            <a:avLst/>
-          </a:prstGeom>
-          <a:noFill/>
-          <a:ln/>
-        </p:spPr>
-        <p:txBody>
-          <a:bodyPr wrap="square" rtlCol="0" anchor="ctr"/>
-          <a:lstStyle/>
-          <a:p>
-            <a:pPr algn="ctr" indent="0" marL="0">
-              <a:buNone/>
-            </a:pPr>
-            <a:r>
-              <a:rPr lang="en-US" sz="1400" b="1" i="1" dirty="0">
-                <a:solidFill>
-                  <a:srgbClr val="21A663"/>
-                </a:solidFill>
-                <a:latin typeface="Calibri" pitchFamily="34" charset="0"/>
-                <a:ea typeface="Calibri" pitchFamily="34" charset="-122"/>
-                <a:cs typeface="Calibri" pitchFamily="34" charset="-120"/>
-              </a:rPr>
-              <a:t>Сейчас здесь →  MVP полностью реализован, идём к пилоту</a:t>
-            </a:r>
-            <a:endParaRPr lang="en-US" sz="1400" dirty="0"/>
+              <a:t>Библиотека сообщества + семантический поиск · оценка 👍/👎 · админ-статистика</a:t>
+            </a:r>
+            <a:endParaRPr lang="en-US" sz="1050" dirty="0"/>
           </a:p>
         </p:txBody>
       </p:sp>

</xml_diff>